<commit_message>
Atualizando PPT/PDF com a EDA no final da análise
</commit_message>
<xml_diff>
--- a/Analfabetismo - Fase 3 - Apresentação Gerencial.pptx
+++ b/Analfabetismo - Fase 3 - Apresentação Gerencial.pptx
@@ -2,22 +2,24 @@
 <file path=ppt/presentation.xml><?xml version="1.0" encoding="utf-8"?>
 <p:presentation xmlns:a="http://schemas.openxmlformats.org/drawingml/2006/main" xmlns:r="http://schemas.openxmlformats.org/officeDocument/2006/relationships" xmlns:mc="http://schemas.openxmlformats.org/markup-compatibility/2006" xmlns:mv="urn:schemas-microsoft-com:mac:vml" xmlns:p="http://schemas.openxmlformats.org/presentationml/2006/main" xmlns:c="http://schemas.openxmlformats.org/drawingml/2006/chart" xmlns:dgm="http://schemas.openxmlformats.org/drawingml/2006/diagram" xmlns:o="urn:schemas-microsoft-com:office:office" xmlns:v="urn:schemas-microsoft-com:vml" xmlns:pvml="urn:schemas-microsoft-com:office:powerpoint" xmlns:com="http://schemas.openxmlformats.org/drawingml/2006/compatibility" xmlns:p14="http://schemas.microsoft.com/office/powerpoint/2010/main" xmlns:p15="http://schemas.microsoft.com/office/powerpoint/2012/main" xmlns:ahyp="http://schemas.microsoft.com/office/drawing/2018/hyperlinkcolor" autoCompressPictures="0" strictFirstAndLastChars="0" saveSubsetFonts="1">
   <p:sldMasterIdLst>
-    <p:sldMasterId id="2147483659" r:id="rId4"/>
+    <p:sldMasterId id="2147483659" r:id="rId5"/>
   </p:sldMasterIdLst>
   <p:notesMasterIdLst>
-    <p:notesMasterId r:id="rId5"/>
+    <p:notesMasterId r:id="rId6"/>
   </p:notesMasterIdLst>
   <p:sldIdLst>
-    <p:sldId id="256" r:id="rId6"/>
-    <p:sldId id="257" r:id="rId7"/>
-    <p:sldId id="258" r:id="rId8"/>
-    <p:sldId id="259" r:id="rId9"/>
-    <p:sldId id="260" r:id="rId10"/>
-    <p:sldId id="261" r:id="rId11"/>
-    <p:sldId id="262" r:id="rId12"/>
-    <p:sldId id="263" r:id="rId13"/>
-    <p:sldId id="264" r:id="rId14"/>
-    <p:sldId id="265" r:id="rId15"/>
+    <p:sldId id="256" r:id="rId7"/>
+    <p:sldId id="257" r:id="rId8"/>
+    <p:sldId id="258" r:id="rId9"/>
+    <p:sldId id="259" r:id="rId10"/>
+    <p:sldId id="260" r:id="rId11"/>
+    <p:sldId id="261" r:id="rId12"/>
+    <p:sldId id="262" r:id="rId13"/>
+    <p:sldId id="263" r:id="rId14"/>
+    <p:sldId id="264" r:id="rId15"/>
+    <p:sldId id="265" r:id="rId16"/>
+    <p:sldId id="266" r:id="rId17"/>
+    <p:sldId id="267" r:id="rId18"/>
   </p:sldIdLst>
   <p:sldSz cy="5143500" cx="9144000"/>
   <p:notesSz cx="6858000" cy="9144000"/>
@@ -799,7 +801,7 @@
   <p:cSld>
     <p:spTree>
       <p:nvGrpSpPr>
-        <p:cNvPr id="116" name="Shape 116"/>
+        <p:cNvPr id="131" name="Shape 131"/>
         <p:cNvGrpSpPr/>
         <p:nvPr/>
       </p:nvGrpSpPr>
@@ -813,7 +815,7 @@
       </p:grpSpPr>
       <p:sp>
         <p:nvSpPr>
-          <p:cNvPr id="117" name="Google Shape;117;g3f3a4b416db_0_0:notes"/>
+          <p:cNvPr id="132" name="Google Shape;132;g3fb6249e16c_0_26:notes"/>
           <p:cNvSpPr/>
           <p:nvPr>
             <p:ph idx="2" type="sldImg"/>
@@ -848,7 +850,205 @@
       </p:sp>
       <p:sp>
         <p:nvSpPr>
-          <p:cNvPr id="118" name="Google Shape;118;g3f3a4b416db_0_0:notes"/>
+          <p:cNvPr id="133" name="Google Shape;133;g3fb6249e16c_0_26:notes"/>
+          <p:cNvSpPr txBox="1"/>
+          <p:nvPr>
+            <p:ph idx="1" type="body"/>
+          </p:nvPr>
+        </p:nvSpPr>
+        <p:spPr>
+          <a:xfrm>
+            <a:off x="685800" y="4343400"/>
+            <a:ext cx="5486400" cy="4114800"/>
+          </a:xfrm>
+          <a:prstGeom prst="rect">
+            <a:avLst/>
+          </a:prstGeom>
+        </p:spPr>
+        <p:txBody>
+          <a:bodyPr anchorCtr="0" anchor="t" bIns="91425" lIns="91425" spcFirstLastPara="1" rIns="91425" wrap="square" tIns="91425">
+            <a:noAutofit/>
+          </a:bodyPr>
+          <a:lstStyle/>
+          <a:p>
+            <a:pPr indent="0" lvl="0" marL="0" rtl="0" algn="l">
+              <a:spcBef>
+                <a:spcPts val="0"/>
+              </a:spcBef>
+              <a:spcAft>
+                <a:spcPts val="0"/>
+              </a:spcAft>
+              <a:buNone/>
+            </a:pPr>
+            <a:r>
+              <a:t/>
+            </a:r>
+            <a:endParaRPr/>
+          </a:p>
+        </p:txBody>
+      </p:sp>
+    </p:spTree>
+  </p:cSld>
+  <p:clrMapOvr>
+    <a:masterClrMapping/>
+  </p:clrMapOvr>
+</p:notes>
+</file>
+
+<file path=ppt/notesSlides/notesSlide11.xml><?xml version="1.0" encoding="utf-8"?>
+<p:notes xmlns:a="http://schemas.openxmlformats.org/drawingml/2006/main" xmlns:r="http://schemas.openxmlformats.org/officeDocument/2006/relationships" xmlns:mc="http://schemas.openxmlformats.org/markup-compatibility/2006" xmlns:mv="urn:schemas-microsoft-com:mac:vml" xmlns:p="http://schemas.openxmlformats.org/presentationml/2006/main" xmlns:c="http://schemas.openxmlformats.org/drawingml/2006/chart" xmlns:dgm="http://schemas.openxmlformats.org/drawingml/2006/diagram" xmlns:o="urn:schemas-microsoft-com:office:office" xmlns:v="urn:schemas-microsoft-com:vml" xmlns:pvml="urn:schemas-microsoft-com:office:powerpoint" xmlns:com="http://schemas.openxmlformats.org/drawingml/2006/compatibility" xmlns:p14="http://schemas.microsoft.com/office/powerpoint/2010/main" xmlns:p15="http://schemas.microsoft.com/office/powerpoint/2012/main" xmlns:ahyp="http://schemas.microsoft.com/office/drawing/2018/hyperlinkcolor" showMasterPhAnim="0" showMasterSp="0">
+  <p:cSld>
+    <p:spTree>
+      <p:nvGrpSpPr>
+        <p:cNvPr id="147" name="Shape 147"/>
+        <p:cNvGrpSpPr/>
+        <p:nvPr/>
+      </p:nvGrpSpPr>
+      <p:grpSpPr>
+        <a:xfrm>
+          <a:off x="0" y="0"/>
+          <a:ext cx="0" cy="0"/>
+          <a:chOff x="0" y="0"/>
+          <a:chExt cx="0" cy="0"/>
+        </a:xfrm>
+      </p:grpSpPr>
+      <p:sp>
+        <p:nvSpPr>
+          <p:cNvPr id="148" name="Google Shape;148;g3fb59bba659_0_4:notes"/>
+          <p:cNvSpPr/>
+          <p:nvPr>
+            <p:ph idx="2" type="sldImg"/>
+          </p:nvPr>
+        </p:nvSpPr>
+        <p:spPr>
+          <a:xfrm>
+            <a:off x="381300" y="685800"/>
+            <a:ext cx="6096000" cy="3429000"/>
+          </a:xfrm>
+          <a:custGeom>
+            <a:rect b="b" l="l" r="r" t="t"/>
+            <a:pathLst>
+              <a:path extrusionOk="0" h="120000" w="120000">
+                <a:moveTo>
+                  <a:pt x="0" y="0"/>
+                </a:moveTo>
+                <a:lnTo>
+                  <a:pt x="120000" y="0"/>
+                </a:lnTo>
+                <a:lnTo>
+                  <a:pt x="120000" y="120000"/>
+                </a:lnTo>
+                <a:lnTo>
+                  <a:pt x="0" y="120000"/>
+                </a:lnTo>
+                <a:close/>
+              </a:path>
+            </a:pathLst>
+          </a:custGeom>
+        </p:spPr>
+      </p:sp>
+      <p:sp>
+        <p:nvSpPr>
+          <p:cNvPr id="149" name="Google Shape;149;g3fb59bba659_0_4:notes"/>
+          <p:cNvSpPr txBox="1"/>
+          <p:nvPr>
+            <p:ph idx="1" type="body"/>
+          </p:nvPr>
+        </p:nvSpPr>
+        <p:spPr>
+          <a:xfrm>
+            <a:off x="685800" y="4343400"/>
+            <a:ext cx="5486400" cy="4114800"/>
+          </a:xfrm>
+          <a:prstGeom prst="rect">
+            <a:avLst/>
+          </a:prstGeom>
+        </p:spPr>
+        <p:txBody>
+          <a:bodyPr anchorCtr="0" anchor="t" bIns="91425" lIns="91425" spcFirstLastPara="1" rIns="91425" wrap="square" tIns="91425">
+            <a:noAutofit/>
+          </a:bodyPr>
+          <a:lstStyle/>
+          <a:p>
+            <a:pPr indent="0" lvl="0" marL="0" rtl="0" algn="l">
+              <a:spcBef>
+                <a:spcPts val="0"/>
+              </a:spcBef>
+              <a:spcAft>
+                <a:spcPts val="0"/>
+              </a:spcAft>
+              <a:buNone/>
+            </a:pPr>
+            <a:r>
+              <a:t/>
+            </a:r>
+            <a:endParaRPr/>
+          </a:p>
+        </p:txBody>
+      </p:sp>
+    </p:spTree>
+  </p:cSld>
+  <p:clrMapOvr>
+    <a:masterClrMapping/>
+  </p:clrMapOvr>
+</p:notes>
+</file>
+
+<file path=ppt/notesSlides/notesSlide12.xml><?xml version="1.0" encoding="utf-8"?>
+<p:notes xmlns:a="http://schemas.openxmlformats.org/drawingml/2006/main" xmlns:r="http://schemas.openxmlformats.org/officeDocument/2006/relationships" xmlns:mc="http://schemas.openxmlformats.org/markup-compatibility/2006" xmlns:mv="urn:schemas-microsoft-com:mac:vml" xmlns:p="http://schemas.openxmlformats.org/presentationml/2006/main" xmlns:c="http://schemas.openxmlformats.org/drawingml/2006/chart" xmlns:dgm="http://schemas.openxmlformats.org/drawingml/2006/diagram" xmlns:o="urn:schemas-microsoft-com:office:office" xmlns:v="urn:schemas-microsoft-com:vml" xmlns:pvml="urn:schemas-microsoft-com:office:powerpoint" xmlns:com="http://schemas.openxmlformats.org/drawingml/2006/compatibility" xmlns:p14="http://schemas.microsoft.com/office/powerpoint/2010/main" xmlns:p15="http://schemas.microsoft.com/office/powerpoint/2012/main" xmlns:ahyp="http://schemas.microsoft.com/office/drawing/2018/hyperlinkcolor" showMasterPhAnim="0" showMasterSp="0">
+  <p:cSld>
+    <p:spTree>
+      <p:nvGrpSpPr>
+        <p:cNvPr id="153" name="Shape 153"/>
+        <p:cNvGrpSpPr/>
+        <p:nvPr/>
+      </p:nvGrpSpPr>
+      <p:grpSpPr>
+        <a:xfrm>
+          <a:off x="0" y="0"/>
+          <a:ext cx="0" cy="0"/>
+          <a:chOff x="0" y="0"/>
+          <a:chExt cx="0" cy="0"/>
+        </a:xfrm>
+      </p:grpSpPr>
+      <p:sp>
+        <p:nvSpPr>
+          <p:cNvPr id="154" name="Google Shape;154;g3f3a4b416db_0_0:notes"/>
+          <p:cNvSpPr/>
+          <p:nvPr>
+            <p:ph idx="2" type="sldImg"/>
+          </p:nvPr>
+        </p:nvSpPr>
+        <p:spPr>
+          <a:xfrm>
+            <a:off x="381300" y="685800"/>
+            <a:ext cx="6096000" cy="3429000"/>
+          </a:xfrm>
+          <a:custGeom>
+            <a:rect b="b" l="l" r="r" t="t"/>
+            <a:pathLst>
+              <a:path extrusionOk="0" h="120000" w="120000">
+                <a:moveTo>
+                  <a:pt x="0" y="0"/>
+                </a:moveTo>
+                <a:lnTo>
+                  <a:pt x="120000" y="0"/>
+                </a:lnTo>
+                <a:lnTo>
+                  <a:pt x="120000" y="120000"/>
+                </a:lnTo>
+                <a:lnTo>
+                  <a:pt x="0" y="120000"/>
+                </a:lnTo>
+                <a:close/>
+              </a:path>
+            </a:pathLst>
+          </a:custGeom>
+        </p:spPr>
+      </p:sp>
+      <p:sp>
+        <p:nvSpPr>
+          <p:cNvPr id="155" name="Google Shape;155;g3f3a4b416db_0_0:notes"/>
           <p:cNvSpPr txBox="1"/>
           <p:nvPr>
             <p:ph idx="1" type="body"/>
@@ -1605,7 +1805,7 @@
       </p:grpSpPr>
       <p:sp>
         <p:nvSpPr>
-          <p:cNvPr id="111" name="Google Shape;111;g3fb59bba659_0_4:notes"/>
+          <p:cNvPr id="111" name="Google Shape;111;g3fb6249e16c_0_0:notes"/>
           <p:cNvSpPr/>
           <p:nvPr>
             <p:ph idx="2" type="sldImg"/>
@@ -1640,7 +1840,7 @@
       </p:sp>
       <p:sp>
         <p:nvSpPr>
-          <p:cNvPr id="112" name="Google Shape;112;g3fb59bba659_0_4:notes"/>
+          <p:cNvPr id="112" name="Google Shape;112;g3fb6249e16c_0_0:notes"/>
           <p:cNvSpPr txBox="1"/>
           <p:nvPr>
             <p:ph idx="1" type="body"/>
@@ -6580,7 +6780,1296 @@
   <p:cSld>
     <p:spTree>
       <p:nvGrpSpPr>
-        <p:cNvPr id="119" name="Shape 119"/>
+        <p:cNvPr id="134" name="Shape 134"/>
+        <p:cNvGrpSpPr/>
+        <p:nvPr/>
+      </p:nvGrpSpPr>
+      <p:grpSpPr>
+        <a:xfrm>
+          <a:off x="0" y="0"/>
+          <a:ext cx="0" cy="0"/>
+          <a:chOff x="0" y="0"/>
+          <a:chExt cx="0" cy="0"/>
+        </a:xfrm>
+      </p:grpSpPr>
+      <p:pic>
+        <p:nvPicPr>
+          <p:cNvPr id="135" name="Google Shape;135;p22" title="correl_var_vs_var.png"/>
+          <p:cNvPicPr preferRelativeResize="0"/>
+          <p:nvPr/>
+        </p:nvPicPr>
+        <p:blipFill>
+          <a:blip r:embed="rId3">
+            <a:alphaModFix/>
+          </a:blip>
+          <a:stretch>
+            <a:fillRect/>
+          </a:stretch>
+        </p:blipFill>
+        <p:spPr>
+          <a:xfrm>
+            <a:off x="166050" y="2739540"/>
+            <a:ext cx="3822100" cy="2293260"/>
+          </a:xfrm>
+          <a:prstGeom prst="rect">
+            <a:avLst/>
+          </a:prstGeom>
+          <a:noFill/>
+          <a:ln>
+            <a:noFill/>
+          </a:ln>
+        </p:spPr>
+      </p:pic>
+      <p:sp>
+        <p:nvSpPr>
+          <p:cNvPr id="136" name="Google Shape;136;p22"/>
+          <p:cNvSpPr txBox="1"/>
+          <p:nvPr>
+            <p:ph type="title"/>
+          </p:nvPr>
+        </p:nvSpPr>
+        <p:spPr>
+          <a:xfrm>
+            <a:off x="311700" y="445025"/>
+            <a:ext cx="8520600" cy="572700"/>
+          </a:xfrm>
+          <a:prstGeom prst="rect">
+            <a:avLst/>
+          </a:prstGeom>
+        </p:spPr>
+        <p:txBody>
+          <a:bodyPr anchorCtr="0" anchor="t" bIns="91425" lIns="91425" spcFirstLastPara="1" rIns="91425" wrap="square" tIns="91425">
+            <a:noAutofit/>
+          </a:bodyPr>
+          <a:lstStyle/>
+          <a:p>
+            <a:pPr indent="0" lvl="0" marL="0" rtl="0" algn="l">
+              <a:spcBef>
+                <a:spcPts val="0"/>
+              </a:spcBef>
+              <a:spcAft>
+                <a:spcPts val="0"/>
+              </a:spcAft>
+              <a:buNone/>
+            </a:pPr>
+            <a:r>
+              <a:rPr lang="en"/>
+              <a:t>Fundeb: impacto negativo na Regressão Logística</a:t>
+            </a:r>
+            <a:endParaRPr/>
+          </a:p>
+        </p:txBody>
+      </p:sp>
+      <p:sp>
+        <p:nvSpPr>
+          <p:cNvPr id="137" name="Google Shape;137;p22"/>
+          <p:cNvSpPr txBox="1"/>
+          <p:nvPr>
+            <p:ph idx="1" type="body"/>
+          </p:nvPr>
+        </p:nvSpPr>
+        <p:spPr>
+          <a:xfrm>
+            <a:off x="311700" y="1092200"/>
+            <a:ext cx="7451400" cy="1205700"/>
+          </a:xfrm>
+          <a:prstGeom prst="rect">
+            <a:avLst/>
+          </a:prstGeom>
+        </p:spPr>
+        <p:txBody>
+          <a:bodyPr anchorCtr="0" anchor="t" bIns="91425" lIns="91425" spcFirstLastPara="1" rIns="91425" wrap="square" tIns="91425">
+            <a:noAutofit/>
+          </a:bodyPr>
+          <a:lstStyle/>
+          <a:p>
+            <a:pPr indent="-317500" lvl="0" marL="457200" rtl="0" algn="l">
+              <a:spcBef>
+                <a:spcPts val="0"/>
+              </a:spcBef>
+              <a:spcAft>
+                <a:spcPts val="0"/>
+              </a:spcAft>
+              <a:buSzPts val="1400"/>
+              <a:buChar char="●"/>
+            </a:pPr>
+            <a:r>
+              <a:rPr lang="en" sz="1400"/>
+              <a:t>Grande variabilidade em ambas variáveis no tempo (‘24 vs ‘23)</a:t>
+            </a:r>
+            <a:endParaRPr sz="1400"/>
+          </a:p>
+          <a:p>
+            <a:pPr indent="-317500" lvl="0" marL="457200" rtl="0" algn="l">
+              <a:spcBef>
+                <a:spcPts val="0"/>
+              </a:spcBef>
+              <a:spcAft>
+                <a:spcPts val="0"/>
+              </a:spcAft>
+              <a:buSzPts val="1400"/>
+              <a:buChar char="●"/>
+            </a:pPr>
+            <a:r>
+              <a:rPr lang="en" sz="1400"/>
+              <a:t>Provavelmente resultado de variáveis políticas, emendas, “orçamento secreto” etc.</a:t>
+            </a:r>
+            <a:endParaRPr sz="1400"/>
+          </a:p>
+          <a:p>
+            <a:pPr indent="-317500" lvl="0" marL="457200" rtl="0" algn="l">
+              <a:spcBef>
+                <a:spcPts val="0"/>
+              </a:spcBef>
+              <a:spcAft>
+                <a:spcPts val="0"/>
+              </a:spcAft>
+              <a:buSzPts val="1400"/>
+              <a:buChar char="●"/>
+            </a:pPr>
+            <a:r>
+              <a:rPr lang="en" sz="1400"/>
+              <a:t>D</a:t>
+            </a:r>
+            <a:r>
+              <a:rPr lang="en" sz="1400"/>
+              <a:t>emais variáveis explicativas do modelo (geográficas, sociais, macroeconômicas): todas fixas ou variando em décadas, não anos </a:t>
+            </a:r>
+            <a:endParaRPr sz="1400"/>
+          </a:p>
+          <a:p>
+            <a:pPr indent="-317500" lvl="0" marL="457200" rtl="0" algn="l">
+              <a:spcBef>
+                <a:spcPts val="0"/>
+              </a:spcBef>
+              <a:spcAft>
+                <a:spcPts val="0"/>
+              </a:spcAft>
+              <a:buSzPts val="1400"/>
+              <a:buChar char="●"/>
+            </a:pPr>
+            <a:r>
+              <a:rPr lang="en" sz="1400"/>
+              <a:t>Dado que usamos 2023 como treino e 2024 como teste, essa variabilidade explica o papel de destaque dessa variável nos modelos</a:t>
+            </a:r>
+            <a:endParaRPr sz="1400"/>
+          </a:p>
+        </p:txBody>
+      </p:sp>
+      <p:graphicFrame>
+        <p:nvGraphicFramePr>
+          <p:cNvPr id="138" name="Google Shape;138;p22"/>
+          <p:cNvGraphicFramePr/>
+          <p:nvPr/>
+        </p:nvGraphicFramePr>
+        <p:xfrm>
+          <a:off x="4395361" y="2908136"/>
+          <a:ext cx="3000000" cy="3000000"/>
+        </p:xfrm>
+        <a:graphic>
+          <a:graphicData uri="http://schemas.openxmlformats.org/drawingml/2006/table">
+            <a:tbl>
+              <a:tblPr>
+                <a:noFill/>
+                <a:tableStyleId>{02E23E79-4A31-47A8-8ED0-94E05C562DE2}</a:tableStyleId>
+              </a:tblPr>
+              <a:tblGrid>
+                <a:gridCol w="1914975"/>
+                <a:gridCol w="684475"/>
+                <a:gridCol w="657975"/>
+                <a:gridCol w="640325"/>
+                <a:gridCol w="568150"/>
+              </a:tblGrid>
+              <a:tr h="427400">
+                <a:tc>
+                  <a:txBody>
+                    <a:bodyPr/>
+                    <a:lstStyle/>
+                    <a:p>
+                      <a:pPr indent="0" lvl="0" marL="0" rtl="0" algn="ctr">
+                        <a:spcBef>
+                          <a:spcPts val="0"/>
+                        </a:spcBef>
+                        <a:spcAft>
+                          <a:spcPts val="0"/>
+                        </a:spcAft>
+                        <a:buNone/>
+                      </a:pPr>
+                      <a:r>
+                        <a:rPr lang="en" sz="900"/>
+                        <a:t>Cidade (pop)</a:t>
+                      </a:r>
+                      <a:endParaRPr sz="900"/>
+                    </a:p>
+                  </a:txBody>
+                  <a:tcPr marT="91425" marB="91425" marR="91425" marL="91425"/>
+                </a:tc>
+                <a:tc>
+                  <a:txBody>
+                    <a:bodyPr/>
+                    <a:lstStyle/>
+                    <a:p>
+                      <a:pPr indent="0" lvl="0" marL="0" rtl="0" algn="ctr">
+                        <a:spcBef>
+                          <a:spcPts val="0"/>
+                        </a:spcBef>
+                        <a:spcAft>
+                          <a:spcPts val="0"/>
+                        </a:spcAft>
+                        <a:buNone/>
+                      </a:pPr>
+                      <a:r>
+                        <a:rPr lang="en" sz="900"/>
+                        <a:t>Var. Fundeb</a:t>
+                      </a:r>
+                      <a:endParaRPr sz="900"/>
+                    </a:p>
+                  </a:txBody>
+                  <a:tcPr marT="91425" marB="91425" marR="91425" marL="91425"/>
+                </a:tc>
+                <a:tc>
+                  <a:txBody>
+                    <a:bodyPr/>
+                    <a:lstStyle/>
+                    <a:p>
+                      <a:pPr indent="0" lvl="0" marL="0" rtl="0" algn="ctr">
+                        <a:spcBef>
+                          <a:spcPts val="0"/>
+                        </a:spcBef>
+                        <a:spcAft>
+                          <a:spcPts val="0"/>
+                        </a:spcAft>
+                        <a:buNone/>
+                      </a:pPr>
+                      <a:r>
+                        <a:rPr lang="en" sz="900"/>
+                        <a:t>Ating. Meta ‘23</a:t>
+                      </a:r>
+                      <a:endParaRPr sz="900"/>
+                    </a:p>
+                  </a:txBody>
+                  <a:tcPr marT="91425" marB="91425" marR="91425" marL="91425"/>
+                </a:tc>
+                <a:tc>
+                  <a:txBody>
+                    <a:bodyPr/>
+                    <a:lstStyle/>
+                    <a:p>
+                      <a:pPr indent="0" lvl="0" marL="0" rtl="0" algn="ctr">
+                        <a:spcBef>
+                          <a:spcPts val="0"/>
+                        </a:spcBef>
+                        <a:spcAft>
+                          <a:spcPts val="0"/>
+                        </a:spcAft>
+                        <a:buNone/>
+                      </a:pPr>
+                      <a:r>
+                        <a:rPr lang="en" sz="900"/>
+                        <a:t>Ating. Meta ‘24</a:t>
+                      </a:r>
+                      <a:endParaRPr sz="900"/>
+                    </a:p>
+                  </a:txBody>
+                  <a:tcPr marT="91425" marB="91425" marR="91425" marL="91425"/>
+                </a:tc>
+                <a:tc>
+                  <a:txBody>
+                    <a:bodyPr/>
+                    <a:lstStyle/>
+                    <a:p>
+                      <a:pPr indent="0" lvl="0" marL="0" rtl="0" algn="ctr">
+                        <a:spcBef>
+                          <a:spcPts val="0"/>
+                        </a:spcBef>
+                        <a:spcAft>
+                          <a:spcPts val="0"/>
+                        </a:spcAft>
+                        <a:buNone/>
+                      </a:pPr>
+                      <a:r>
+                        <a:rPr lang="en" sz="900"/>
+                        <a:t>Var Ating.</a:t>
+                      </a:r>
+                      <a:endParaRPr sz="900"/>
+                    </a:p>
+                  </a:txBody>
+                  <a:tcPr marT="91425" marB="91425" marR="91425" marL="91425"/>
+                </a:tc>
+              </a:tr>
+              <a:tr h="345775">
+                <a:tc>
+                  <a:txBody>
+                    <a:bodyPr/>
+                    <a:lstStyle/>
+                    <a:p>
+                      <a:pPr indent="0" lvl="0" marL="0" rtl="0" algn="ctr">
+                        <a:spcBef>
+                          <a:spcPts val="0"/>
+                        </a:spcBef>
+                        <a:spcAft>
+                          <a:spcPts val="0"/>
+                        </a:spcAft>
+                        <a:buNone/>
+                      </a:pPr>
+                      <a:r>
+                        <a:rPr lang="en" sz="900"/>
+                        <a:t>Cel. Fabriciano/MG (104k)</a:t>
+                      </a:r>
+                      <a:endParaRPr sz="900"/>
+                    </a:p>
+                  </a:txBody>
+                  <a:tcPr marT="91425" marB="91425" marR="91425" marL="91425"/>
+                </a:tc>
+                <a:tc>
+                  <a:txBody>
+                    <a:bodyPr/>
+                    <a:lstStyle/>
+                    <a:p>
+                      <a:pPr indent="0" lvl="0" marL="0" rtl="0" algn="ctr">
+                        <a:spcBef>
+                          <a:spcPts val="0"/>
+                        </a:spcBef>
+                        <a:spcAft>
+                          <a:spcPts val="0"/>
+                        </a:spcAft>
+                        <a:buNone/>
+                      </a:pPr>
+                      <a:r>
+                        <a:rPr b="1" lang="en" sz="900">
+                          <a:solidFill>
+                            <a:srgbClr val="0000FF"/>
+                          </a:solidFill>
+                        </a:rPr>
+                        <a:t>+21%</a:t>
+                      </a:r>
+                      <a:endParaRPr b="1" sz="900">
+                        <a:solidFill>
+                          <a:srgbClr val="0000FF"/>
+                        </a:solidFill>
+                      </a:endParaRPr>
+                    </a:p>
+                  </a:txBody>
+                  <a:tcPr marT="91425" marB="91425" marR="91425" marL="91425"/>
+                </a:tc>
+                <a:tc>
+                  <a:txBody>
+                    <a:bodyPr/>
+                    <a:lstStyle/>
+                    <a:p>
+                      <a:pPr indent="0" lvl="0" marL="0" rtl="0" algn="ctr">
+                        <a:spcBef>
+                          <a:spcPts val="0"/>
+                        </a:spcBef>
+                        <a:spcAft>
+                          <a:spcPts val="0"/>
+                        </a:spcAft>
+                        <a:buNone/>
+                      </a:pPr>
+                      <a:r>
+                        <a:rPr lang="en" sz="900"/>
+                        <a:t>-10pp</a:t>
+                      </a:r>
+                      <a:endParaRPr sz="900"/>
+                    </a:p>
+                  </a:txBody>
+                  <a:tcPr marT="91425" marB="91425" marR="91425" marL="91425"/>
+                </a:tc>
+                <a:tc>
+                  <a:txBody>
+                    <a:bodyPr/>
+                    <a:lstStyle/>
+                    <a:p>
+                      <a:pPr indent="0" lvl="0" marL="0" marR="0" rtl="0" algn="ctr">
+                        <a:lnSpc>
+                          <a:spcPct val="100000"/>
+                        </a:lnSpc>
+                        <a:spcBef>
+                          <a:spcPts val="0"/>
+                        </a:spcBef>
+                        <a:spcAft>
+                          <a:spcPts val="0"/>
+                        </a:spcAft>
+                        <a:buNone/>
+                      </a:pPr>
+                      <a:r>
+                        <a:rPr lang="en" sz="900"/>
+                        <a:t>+6pp</a:t>
+                      </a:r>
+                      <a:endParaRPr sz="900"/>
+                    </a:p>
+                  </a:txBody>
+                  <a:tcPr marT="91425" marB="91425" marR="91425" marL="91425"/>
+                </a:tc>
+                <a:tc>
+                  <a:txBody>
+                    <a:bodyPr/>
+                    <a:lstStyle/>
+                    <a:p>
+                      <a:pPr indent="0" lvl="0" marL="0" marR="0" rtl="0" algn="ctr">
+                        <a:lnSpc>
+                          <a:spcPct val="100000"/>
+                        </a:lnSpc>
+                        <a:spcBef>
+                          <a:spcPts val="0"/>
+                        </a:spcBef>
+                        <a:spcAft>
+                          <a:spcPts val="0"/>
+                        </a:spcAft>
+                        <a:buNone/>
+                      </a:pPr>
+                      <a:r>
+                        <a:rPr b="1" lang="en" sz="900">
+                          <a:solidFill>
+                            <a:srgbClr val="0000FF"/>
+                          </a:solidFill>
+                        </a:rPr>
+                        <a:t>+16pp</a:t>
+                      </a:r>
+                      <a:endParaRPr b="1" sz="900">
+                        <a:solidFill>
+                          <a:srgbClr val="0000FF"/>
+                        </a:solidFill>
+                      </a:endParaRPr>
+                    </a:p>
+                  </a:txBody>
+                  <a:tcPr marT="91425" marB="91425" marR="91425" marL="91425"/>
+                </a:tc>
+              </a:tr>
+              <a:tr h="146200">
+                <a:tc>
+                  <a:txBody>
+                    <a:bodyPr/>
+                    <a:lstStyle/>
+                    <a:p>
+                      <a:pPr indent="0" lvl="0" marL="0" rtl="0" algn="ctr">
+                        <a:spcBef>
+                          <a:spcPts val="0"/>
+                        </a:spcBef>
+                        <a:spcAft>
+                          <a:spcPts val="0"/>
+                        </a:spcAft>
+                        <a:buNone/>
+                      </a:pPr>
+                      <a:r>
+                        <a:rPr lang="en" sz="900"/>
+                        <a:t>São Borja/RS (59k)</a:t>
+                      </a:r>
+                      <a:endParaRPr sz="900"/>
+                    </a:p>
+                  </a:txBody>
+                  <a:tcPr marT="91425" marB="91425" marR="91425" marL="91425"/>
+                </a:tc>
+                <a:tc>
+                  <a:txBody>
+                    <a:bodyPr/>
+                    <a:lstStyle/>
+                    <a:p>
+                      <a:pPr indent="0" lvl="0" marL="0" rtl="0" algn="ctr">
+                        <a:spcBef>
+                          <a:spcPts val="0"/>
+                        </a:spcBef>
+                        <a:spcAft>
+                          <a:spcPts val="0"/>
+                        </a:spcAft>
+                        <a:buNone/>
+                      </a:pPr>
+                      <a:r>
+                        <a:rPr b="1" lang="en" sz="900">
+                          <a:solidFill>
+                            <a:srgbClr val="0000FF"/>
+                          </a:solidFill>
+                        </a:rPr>
+                        <a:t>+23%</a:t>
+                      </a:r>
+                      <a:endParaRPr b="1" sz="900">
+                        <a:solidFill>
+                          <a:srgbClr val="0000FF"/>
+                        </a:solidFill>
+                      </a:endParaRPr>
+                    </a:p>
+                  </a:txBody>
+                  <a:tcPr marT="91425" marB="91425" marR="91425" marL="91425"/>
+                </a:tc>
+                <a:tc>
+                  <a:txBody>
+                    <a:bodyPr/>
+                    <a:lstStyle/>
+                    <a:p>
+                      <a:pPr indent="0" lvl="0" marL="0" rtl="0" algn="ctr">
+                        <a:spcBef>
+                          <a:spcPts val="0"/>
+                        </a:spcBef>
+                        <a:spcAft>
+                          <a:spcPts val="0"/>
+                        </a:spcAft>
+                        <a:buNone/>
+                      </a:pPr>
+                      <a:r>
+                        <a:rPr lang="en" sz="900"/>
+                        <a:t>-6pp</a:t>
+                      </a:r>
+                      <a:endParaRPr sz="900"/>
+                    </a:p>
+                  </a:txBody>
+                  <a:tcPr marT="91425" marB="91425" marR="91425" marL="91425"/>
+                </a:tc>
+                <a:tc>
+                  <a:txBody>
+                    <a:bodyPr/>
+                    <a:lstStyle/>
+                    <a:p>
+                      <a:pPr indent="0" lvl="0" marL="0" marR="0" rtl="0" algn="ctr">
+                        <a:lnSpc>
+                          <a:spcPct val="100000"/>
+                        </a:lnSpc>
+                        <a:spcBef>
+                          <a:spcPts val="0"/>
+                        </a:spcBef>
+                        <a:spcAft>
+                          <a:spcPts val="0"/>
+                        </a:spcAft>
+                        <a:buNone/>
+                      </a:pPr>
+                      <a:r>
+                        <a:rPr lang="en" sz="900"/>
+                        <a:t>-23pp</a:t>
+                      </a:r>
+                      <a:endParaRPr sz="900"/>
+                    </a:p>
+                  </a:txBody>
+                  <a:tcPr marT="91425" marB="91425" marR="91425" marL="91425"/>
+                </a:tc>
+                <a:tc>
+                  <a:txBody>
+                    <a:bodyPr/>
+                    <a:lstStyle/>
+                    <a:p>
+                      <a:pPr indent="0" lvl="0" marL="0" rtl="0" algn="ctr">
+                        <a:spcBef>
+                          <a:spcPts val="0"/>
+                        </a:spcBef>
+                        <a:spcAft>
+                          <a:spcPts val="0"/>
+                        </a:spcAft>
+                        <a:buNone/>
+                      </a:pPr>
+                      <a:r>
+                        <a:rPr b="1" lang="en" sz="900">
+                          <a:solidFill>
+                            <a:srgbClr val="FF0000"/>
+                          </a:solidFill>
+                        </a:rPr>
+                        <a:t>-17pp</a:t>
+                      </a:r>
+                      <a:endParaRPr b="1" sz="900">
+                        <a:solidFill>
+                          <a:srgbClr val="FF0000"/>
+                        </a:solidFill>
+                      </a:endParaRPr>
+                    </a:p>
+                  </a:txBody>
+                  <a:tcPr marT="91425" marB="91425" marR="91425" marL="91425"/>
+                </a:tc>
+              </a:tr>
+              <a:tr h="100850">
+                <a:tc>
+                  <a:txBody>
+                    <a:bodyPr/>
+                    <a:lstStyle/>
+                    <a:p>
+                      <a:pPr indent="0" lvl="0" marL="0" rtl="0" algn="ctr">
+                        <a:spcBef>
+                          <a:spcPts val="0"/>
+                        </a:spcBef>
+                        <a:spcAft>
+                          <a:spcPts val="0"/>
+                        </a:spcAft>
+                        <a:buNone/>
+                      </a:pPr>
+                      <a:r>
+                        <a:rPr lang="en" sz="900"/>
+                        <a:t>Breves/PA (107k)</a:t>
+                      </a:r>
+                      <a:endParaRPr sz="900"/>
+                    </a:p>
+                  </a:txBody>
+                  <a:tcPr marT="91425" marB="91425" marR="91425" marL="91425"/>
+                </a:tc>
+                <a:tc>
+                  <a:txBody>
+                    <a:bodyPr/>
+                    <a:lstStyle/>
+                    <a:p>
+                      <a:pPr indent="0" lvl="0" marL="0" rtl="0" algn="ctr">
+                        <a:spcBef>
+                          <a:spcPts val="0"/>
+                        </a:spcBef>
+                        <a:spcAft>
+                          <a:spcPts val="0"/>
+                        </a:spcAft>
+                        <a:buNone/>
+                      </a:pPr>
+                      <a:r>
+                        <a:rPr b="1" lang="en" sz="900">
+                          <a:solidFill>
+                            <a:srgbClr val="FF0000"/>
+                          </a:solidFill>
+                        </a:rPr>
+                        <a:t>-19%</a:t>
+                      </a:r>
+                      <a:endParaRPr b="1" sz="900">
+                        <a:solidFill>
+                          <a:srgbClr val="FF0000"/>
+                        </a:solidFill>
+                      </a:endParaRPr>
+                    </a:p>
+                  </a:txBody>
+                  <a:tcPr marT="91425" marB="91425" marR="91425" marL="91425"/>
+                </a:tc>
+                <a:tc>
+                  <a:txBody>
+                    <a:bodyPr/>
+                    <a:lstStyle/>
+                    <a:p>
+                      <a:pPr indent="0" lvl="0" marL="0" rtl="0" algn="ctr">
+                        <a:spcBef>
+                          <a:spcPts val="0"/>
+                        </a:spcBef>
+                        <a:spcAft>
+                          <a:spcPts val="0"/>
+                        </a:spcAft>
+                        <a:buNone/>
+                      </a:pPr>
+                      <a:r>
+                        <a:rPr lang="en" sz="900"/>
+                        <a:t>-11pp</a:t>
+                      </a:r>
+                      <a:endParaRPr sz="900"/>
+                    </a:p>
+                  </a:txBody>
+                  <a:tcPr marT="91425" marB="91425" marR="91425" marL="91425"/>
+                </a:tc>
+                <a:tc>
+                  <a:txBody>
+                    <a:bodyPr/>
+                    <a:lstStyle/>
+                    <a:p>
+                      <a:pPr indent="0" lvl="0" marL="0" marR="0" rtl="0" algn="ctr">
+                        <a:lnSpc>
+                          <a:spcPct val="100000"/>
+                        </a:lnSpc>
+                        <a:spcBef>
+                          <a:spcPts val="0"/>
+                        </a:spcBef>
+                        <a:spcAft>
+                          <a:spcPts val="0"/>
+                        </a:spcAft>
+                        <a:buNone/>
+                      </a:pPr>
+                      <a:r>
+                        <a:rPr lang="en" sz="900"/>
+                        <a:t>+1pp</a:t>
+                      </a:r>
+                      <a:endParaRPr sz="900"/>
+                    </a:p>
+                  </a:txBody>
+                  <a:tcPr marT="91425" marB="91425" marR="91425" marL="91425"/>
+                </a:tc>
+                <a:tc>
+                  <a:txBody>
+                    <a:bodyPr/>
+                    <a:lstStyle/>
+                    <a:p>
+                      <a:pPr indent="0" lvl="0" marL="0" rtl="0" algn="ctr">
+                        <a:spcBef>
+                          <a:spcPts val="0"/>
+                        </a:spcBef>
+                        <a:spcAft>
+                          <a:spcPts val="0"/>
+                        </a:spcAft>
+                        <a:buNone/>
+                      </a:pPr>
+                      <a:r>
+                        <a:rPr b="1" lang="en" sz="900">
+                          <a:solidFill>
+                            <a:srgbClr val="0000FF"/>
+                          </a:solidFill>
+                        </a:rPr>
+                        <a:t>+12pp</a:t>
+                      </a:r>
+                      <a:endParaRPr b="1" sz="900">
+                        <a:solidFill>
+                          <a:srgbClr val="0000FF"/>
+                        </a:solidFill>
+                      </a:endParaRPr>
+                    </a:p>
+                  </a:txBody>
+                  <a:tcPr marT="91425" marB="91425" marR="91425" marL="91425"/>
+                </a:tc>
+              </a:tr>
+              <a:tr h="236900">
+                <a:tc>
+                  <a:txBody>
+                    <a:bodyPr/>
+                    <a:lstStyle/>
+                    <a:p>
+                      <a:pPr indent="0" lvl="0" marL="0" rtl="0" algn="ctr">
+                        <a:spcBef>
+                          <a:spcPts val="0"/>
+                        </a:spcBef>
+                        <a:spcAft>
+                          <a:spcPts val="0"/>
+                        </a:spcAft>
+                        <a:buNone/>
+                      </a:pPr>
+                      <a:r>
+                        <a:rPr lang="en" sz="900"/>
+                        <a:t>Iranduba/AL (61k)</a:t>
+                      </a:r>
+                      <a:endParaRPr b="1" sz="900"/>
+                    </a:p>
+                  </a:txBody>
+                  <a:tcPr marT="91425" marB="91425" marR="91425" marL="91425"/>
+                </a:tc>
+                <a:tc>
+                  <a:txBody>
+                    <a:bodyPr/>
+                    <a:lstStyle/>
+                    <a:p>
+                      <a:pPr indent="0" lvl="0" marL="0" rtl="0" algn="ctr">
+                        <a:spcBef>
+                          <a:spcPts val="0"/>
+                        </a:spcBef>
+                        <a:spcAft>
+                          <a:spcPts val="0"/>
+                        </a:spcAft>
+                        <a:buNone/>
+                      </a:pPr>
+                      <a:r>
+                        <a:rPr b="1" lang="en" sz="900">
+                          <a:solidFill>
+                            <a:srgbClr val="FF0000"/>
+                          </a:solidFill>
+                        </a:rPr>
+                        <a:t>-18%</a:t>
+                      </a:r>
+                      <a:endParaRPr b="1" sz="900">
+                        <a:solidFill>
+                          <a:srgbClr val="FF0000"/>
+                        </a:solidFill>
+                      </a:endParaRPr>
+                    </a:p>
+                  </a:txBody>
+                  <a:tcPr marT="91425" marB="91425" marR="91425" marL="91425"/>
+                </a:tc>
+                <a:tc>
+                  <a:txBody>
+                    <a:bodyPr/>
+                    <a:lstStyle/>
+                    <a:p>
+                      <a:pPr indent="0" lvl="0" marL="0" rtl="0" algn="ctr">
+                        <a:spcBef>
+                          <a:spcPts val="0"/>
+                        </a:spcBef>
+                        <a:spcAft>
+                          <a:spcPts val="0"/>
+                        </a:spcAft>
+                        <a:buNone/>
+                      </a:pPr>
+                      <a:r>
+                        <a:rPr lang="en" sz="900"/>
+                        <a:t>-11pp</a:t>
+                      </a:r>
+                      <a:endParaRPr sz="900"/>
+                    </a:p>
+                  </a:txBody>
+                  <a:tcPr marT="91425" marB="91425" marR="91425" marL="91425"/>
+                </a:tc>
+                <a:tc>
+                  <a:txBody>
+                    <a:bodyPr/>
+                    <a:lstStyle/>
+                    <a:p>
+                      <a:pPr indent="0" lvl="0" marL="0" marR="0" rtl="0" algn="ctr">
+                        <a:lnSpc>
+                          <a:spcPct val="100000"/>
+                        </a:lnSpc>
+                        <a:spcBef>
+                          <a:spcPts val="0"/>
+                        </a:spcBef>
+                        <a:spcAft>
+                          <a:spcPts val="0"/>
+                        </a:spcAft>
+                        <a:buNone/>
+                      </a:pPr>
+                      <a:r>
+                        <a:rPr lang="en" sz="900"/>
+                        <a:t>-19pp</a:t>
+                      </a:r>
+                      <a:endParaRPr sz="900"/>
+                    </a:p>
+                  </a:txBody>
+                  <a:tcPr marT="91425" marB="91425" marR="91425" marL="91425"/>
+                </a:tc>
+                <a:tc>
+                  <a:txBody>
+                    <a:bodyPr/>
+                    <a:lstStyle/>
+                    <a:p>
+                      <a:pPr indent="0" lvl="0" marL="0" rtl="0" algn="ctr">
+                        <a:spcBef>
+                          <a:spcPts val="0"/>
+                        </a:spcBef>
+                        <a:spcAft>
+                          <a:spcPts val="0"/>
+                        </a:spcAft>
+                        <a:buNone/>
+                      </a:pPr>
+                      <a:r>
+                        <a:rPr b="1" lang="en" sz="900">
+                          <a:solidFill>
+                            <a:srgbClr val="FF0000"/>
+                          </a:solidFill>
+                        </a:rPr>
+                        <a:t>-8pp</a:t>
+                      </a:r>
+                      <a:endParaRPr b="1" sz="900">
+                        <a:solidFill>
+                          <a:srgbClr val="FF0000"/>
+                        </a:solidFill>
+                      </a:endParaRPr>
+                    </a:p>
+                  </a:txBody>
+                  <a:tcPr marT="91425" marB="91425" marR="91425" marL="91425"/>
+                </a:tc>
+              </a:tr>
+            </a:tbl>
+          </a:graphicData>
+        </a:graphic>
+      </p:graphicFrame>
+      <p:sp>
+        <p:nvSpPr>
+          <p:cNvPr id="139" name="Google Shape;139;p22"/>
+          <p:cNvSpPr/>
+          <p:nvPr/>
+        </p:nvSpPr>
+        <p:spPr>
+          <a:xfrm>
+            <a:off x="2058948" y="3738343"/>
+            <a:ext cx="120300" cy="121500"/>
+          </a:xfrm>
+          <a:prstGeom prst="ellipse">
+            <a:avLst/>
+          </a:prstGeom>
+          <a:solidFill>
+            <a:srgbClr val="00D3E6"/>
+          </a:solidFill>
+          <a:ln cap="flat" cmpd="sng" w="9525">
+            <a:solidFill>
+              <a:schemeClr val="dk2"/>
+            </a:solidFill>
+            <a:prstDash val="solid"/>
+            <a:round/>
+            <a:headEnd len="sm" w="sm" type="none"/>
+            <a:tailEnd len="sm" w="sm" type="none"/>
+          </a:ln>
+        </p:spPr>
+        <p:txBody>
+          <a:bodyPr anchorCtr="0" anchor="ctr" bIns="91425" lIns="91425" spcFirstLastPara="1" rIns="91425" wrap="square" tIns="91425">
+            <a:noAutofit/>
+          </a:bodyPr>
+          <a:lstStyle/>
+          <a:p>
+            <a:pPr indent="0" lvl="0" marL="0" rtl="0" algn="ctr">
+              <a:spcBef>
+                <a:spcPts val="0"/>
+              </a:spcBef>
+              <a:spcAft>
+                <a:spcPts val="0"/>
+              </a:spcAft>
+              <a:buNone/>
+            </a:pPr>
+            <a:r>
+              <a:t/>
+            </a:r>
+            <a:endParaRPr>
+              <a:solidFill>
+                <a:srgbClr val="CFE2F3"/>
+              </a:solidFill>
+            </a:endParaRPr>
+          </a:p>
+        </p:txBody>
+      </p:sp>
+      <p:sp>
+        <p:nvSpPr>
+          <p:cNvPr id="140" name="Google Shape;140;p22"/>
+          <p:cNvSpPr/>
+          <p:nvPr/>
+        </p:nvSpPr>
+        <p:spPr>
+          <a:xfrm>
+            <a:off x="2079051" y="4291773"/>
+            <a:ext cx="120300" cy="121500"/>
+          </a:xfrm>
+          <a:prstGeom prst="ellipse">
+            <a:avLst/>
+          </a:prstGeom>
+          <a:solidFill>
+            <a:schemeClr val="accent4"/>
+          </a:solidFill>
+          <a:ln cap="flat" cmpd="sng" w="9525">
+            <a:solidFill>
+              <a:schemeClr val="dk2"/>
+            </a:solidFill>
+            <a:prstDash val="solid"/>
+            <a:round/>
+            <a:headEnd len="sm" w="sm" type="none"/>
+            <a:tailEnd len="sm" w="sm" type="none"/>
+          </a:ln>
+        </p:spPr>
+        <p:txBody>
+          <a:bodyPr anchorCtr="0" anchor="ctr" bIns="91425" lIns="91425" spcFirstLastPara="1" rIns="91425" wrap="square" tIns="91425">
+            <a:noAutofit/>
+          </a:bodyPr>
+          <a:lstStyle/>
+          <a:p>
+            <a:pPr indent="0" lvl="0" marL="0" rtl="0" algn="ctr">
+              <a:spcBef>
+                <a:spcPts val="0"/>
+              </a:spcBef>
+              <a:spcAft>
+                <a:spcPts val="0"/>
+              </a:spcAft>
+              <a:buNone/>
+            </a:pPr>
+            <a:r>
+              <a:t/>
+            </a:r>
+            <a:endParaRPr/>
+          </a:p>
+        </p:txBody>
+      </p:sp>
+      <p:sp>
+        <p:nvSpPr>
+          <p:cNvPr id="141" name="Google Shape;141;p22"/>
+          <p:cNvSpPr/>
+          <p:nvPr/>
+        </p:nvSpPr>
+        <p:spPr>
+          <a:xfrm>
+            <a:off x="4745333" y="4455135"/>
+            <a:ext cx="120300" cy="121500"/>
+          </a:xfrm>
+          <a:prstGeom prst="ellipse">
+            <a:avLst/>
+          </a:prstGeom>
+          <a:solidFill>
+            <a:srgbClr val="CC0000"/>
+          </a:solidFill>
+          <a:ln cap="flat" cmpd="sng" w="9525">
+            <a:solidFill>
+              <a:schemeClr val="dk2"/>
+            </a:solidFill>
+            <a:prstDash val="solid"/>
+            <a:round/>
+            <a:headEnd len="sm" w="sm" type="none"/>
+            <a:tailEnd len="sm" w="sm" type="none"/>
+          </a:ln>
+        </p:spPr>
+        <p:txBody>
+          <a:bodyPr anchorCtr="0" anchor="ctr" bIns="91425" lIns="91425" spcFirstLastPara="1" rIns="91425" wrap="square" tIns="91425">
+            <a:noAutofit/>
+          </a:bodyPr>
+          <a:lstStyle/>
+          <a:p>
+            <a:pPr indent="0" lvl="0" marL="0" rtl="0" algn="ctr">
+              <a:spcBef>
+                <a:spcPts val="0"/>
+              </a:spcBef>
+              <a:spcAft>
+                <a:spcPts val="0"/>
+              </a:spcAft>
+              <a:buNone/>
+            </a:pPr>
+            <a:r>
+              <a:t/>
+            </a:r>
+            <a:endParaRPr/>
+          </a:p>
+        </p:txBody>
+      </p:sp>
+      <p:sp>
+        <p:nvSpPr>
+          <p:cNvPr id="142" name="Google Shape;142;p22"/>
+          <p:cNvSpPr/>
+          <p:nvPr/>
+        </p:nvSpPr>
+        <p:spPr>
+          <a:xfrm>
+            <a:off x="4767016" y="4126012"/>
+            <a:ext cx="120300" cy="121500"/>
+          </a:xfrm>
+          <a:prstGeom prst="ellipse">
+            <a:avLst/>
+          </a:prstGeom>
+          <a:solidFill>
+            <a:schemeClr val="accent5"/>
+          </a:solidFill>
+          <a:ln cap="flat" cmpd="sng" w="9525">
+            <a:solidFill>
+              <a:schemeClr val="dk2"/>
+            </a:solidFill>
+            <a:prstDash val="solid"/>
+            <a:round/>
+            <a:headEnd len="sm" w="sm" type="none"/>
+            <a:tailEnd len="sm" w="sm" type="none"/>
+          </a:ln>
+        </p:spPr>
+        <p:txBody>
+          <a:bodyPr anchorCtr="0" anchor="ctr" bIns="91425" lIns="91425" spcFirstLastPara="1" rIns="91425" wrap="square" tIns="91425">
+            <a:noAutofit/>
+          </a:bodyPr>
+          <a:lstStyle/>
+          <a:p>
+            <a:pPr indent="0" lvl="0" marL="0" rtl="0" algn="ctr">
+              <a:spcBef>
+                <a:spcPts val="0"/>
+              </a:spcBef>
+              <a:spcAft>
+                <a:spcPts val="0"/>
+              </a:spcAft>
+              <a:buNone/>
+            </a:pPr>
+            <a:r>
+              <a:t/>
+            </a:r>
+            <a:endParaRPr>
+              <a:solidFill>
+                <a:srgbClr val="A64D79"/>
+              </a:solidFill>
+            </a:endParaRPr>
+          </a:p>
+        </p:txBody>
+      </p:sp>
+      <p:sp>
+        <p:nvSpPr>
+          <p:cNvPr id="143" name="Google Shape;143;p22"/>
+          <p:cNvSpPr/>
+          <p:nvPr/>
+        </p:nvSpPr>
+        <p:spPr>
+          <a:xfrm>
+            <a:off x="4529905" y="3462764"/>
+            <a:ext cx="120300" cy="121500"/>
+          </a:xfrm>
+          <a:prstGeom prst="ellipse">
+            <a:avLst/>
+          </a:prstGeom>
+          <a:solidFill>
+            <a:srgbClr val="00D3E6"/>
+          </a:solidFill>
+          <a:ln cap="flat" cmpd="sng" w="9525">
+            <a:solidFill>
+              <a:schemeClr val="dk2"/>
+            </a:solidFill>
+            <a:prstDash val="solid"/>
+            <a:round/>
+            <a:headEnd len="sm" w="sm" type="none"/>
+            <a:tailEnd len="sm" w="sm" type="none"/>
+          </a:ln>
+        </p:spPr>
+        <p:txBody>
+          <a:bodyPr anchorCtr="0" anchor="ctr" bIns="91425" lIns="91425" spcFirstLastPara="1" rIns="91425" wrap="square" tIns="91425">
+            <a:noAutofit/>
+          </a:bodyPr>
+          <a:lstStyle/>
+          <a:p>
+            <a:pPr indent="0" lvl="0" marL="0" rtl="0" algn="ctr">
+              <a:spcBef>
+                <a:spcPts val="0"/>
+              </a:spcBef>
+              <a:spcAft>
+                <a:spcPts val="0"/>
+              </a:spcAft>
+              <a:buNone/>
+            </a:pPr>
+            <a:r>
+              <a:t/>
+            </a:r>
+            <a:endParaRPr>
+              <a:solidFill>
+                <a:srgbClr val="CFE2F3"/>
+              </a:solidFill>
+            </a:endParaRPr>
+          </a:p>
+        </p:txBody>
+      </p:sp>
+      <p:sp>
+        <p:nvSpPr>
+          <p:cNvPr id="144" name="Google Shape;144;p22"/>
+          <p:cNvSpPr/>
+          <p:nvPr/>
+        </p:nvSpPr>
+        <p:spPr>
+          <a:xfrm>
+            <a:off x="4715767" y="3807312"/>
+            <a:ext cx="120300" cy="121500"/>
+          </a:xfrm>
+          <a:prstGeom prst="ellipse">
+            <a:avLst/>
+          </a:prstGeom>
+          <a:solidFill>
+            <a:schemeClr val="accent4"/>
+          </a:solidFill>
+          <a:ln cap="flat" cmpd="sng" w="9525">
+            <a:solidFill>
+              <a:schemeClr val="dk2"/>
+            </a:solidFill>
+            <a:prstDash val="solid"/>
+            <a:round/>
+            <a:headEnd len="sm" w="sm" type="none"/>
+            <a:tailEnd len="sm" w="sm" type="none"/>
+          </a:ln>
+        </p:spPr>
+        <p:txBody>
+          <a:bodyPr anchorCtr="0" anchor="ctr" bIns="91425" lIns="91425" spcFirstLastPara="1" rIns="91425" wrap="square" tIns="91425">
+            <a:noAutofit/>
+          </a:bodyPr>
+          <a:lstStyle/>
+          <a:p>
+            <a:pPr indent="0" lvl="0" marL="0" rtl="0" algn="ctr">
+              <a:spcBef>
+                <a:spcPts val="0"/>
+              </a:spcBef>
+              <a:spcAft>
+                <a:spcPts val="0"/>
+              </a:spcAft>
+              <a:buNone/>
+            </a:pPr>
+            <a:r>
+              <a:t/>
+            </a:r>
+            <a:endParaRPr/>
+          </a:p>
+        </p:txBody>
+      </p:sp>
+      <p:sp>
+        <p:nvSpPr>
+          <p:cNvPr id="145" name="Google Shape;145;p22"/>
+          <p:cNvSpPr/>
+          <p:nvPr/>
+        </p:nvSpPr>
+        <p:spPr>
+          <a:xfrm>
+            <a:off x="1173815" y="4184420"/>
+            <a:ext cx="120300" cy="121500"/>
+          </a:xfrm>
+          <a:prstGeom prst="ellipse">
+            <a:avLst/>
+          </a:prstGeom>
+          <a:solidFill>
+            <a:srgbClr val="CC0000"/>
+          </a:solidFill>
+          <a:ln cap="flat" cmpd="sng" w="9525">
+            <a:solidFill>
+              <a:schemeClr val="dk2"/>
+            </a:solidFill>
+            <a:prstDash val="solid"/>
+            <a:round/>
+            <a:headEnd len="sm" w="sm" type="none"/>
+            <a:tailEnd len="sm" w="sm" type="none"/>
+          </a:ln>
+        </p:spPr>
+        <p:txBody>
+          <a:bodyPr anchorCtr="0" anchor="ctr" bIns="91425" lIns="91425" spcFirstLastPara="1" rIns="91425" wrap="square" tIns="91425">
+            <a:noAutofit/>
+          </a:bodyPr>
+          <a:lstStyle/>
+          <a:p>
+            <a:pPr indent="0" lvl="0" marL="0" rtl="0" algn="ctr">
+              <a:spcBef>
+                <a:spcPts val="0"/>
+              </a:spcBef>
+              <a:spcAft>
+                <a:spcPts val="0"/>
+              </a:spcAft>
+              <a:buNone/>
+            </a:pPr>
+            <a:r>
+              <a:t/>
+            </a:r>
+            <a:endParaRPr/>
+          </a:p>
+        </p:txBody>
+      </p:sp>
+      <p:sp>
+        <p:nvSpPr>
+          <p:cNvPr id="146" name="Google Shape;146;p22"/>
+          <p:cNvSpPr/>
+          <p:nvPr/>
+        </p:nvSpPr>
+        <p:spPr>
+          <a:xfrm>
+            <a:off x="1125355" y="3782705"/>
+            <a:ext cx="120300" cy="121500"/>
+          </a:xfrm>
+          <a:prstGeom prst="ellipse">
+            <a:avLst/>
+          </a:prstGeom>
+          <a:solidFill>
+            <a:schemeClr val="accent5"/>
+          </a:solidFill>
+          <a:ln cap="flat" cmpd="sng" w="9525">
+            <a:solidFill>
+              <a:schemeClr val="dk2"/>
+            </a:solidFill>
+            <a:prstDash val="solid"/>
+            <a:round/>
+            <a:headEnd len="sm" w="sm" type="none"/>
+            <a:tailEnd len="sm" w="sm" type="none"/>
+          </a:ln>
+        </p:spPr>
+        <p:txBody>
+          <a:bodyPr anchorCtr="0" anchor="ctr" bIns="91425" lIns="91425" spcFirstLastPara="1" rIns="91425" wrap="square" tIns="91425">
+            <a:noAutofit/>
+          </a:bodyPr>
+          <a:lstStyle/>
+          <a:p>
+            <a:pPr indent="0" lvl="0" marL="0" rtl="0" algn="ctr">
+              <a:spcBef>
+                <a:spcPts val="0"/>
+              </a:spcBef>
+              <a:spcAft>
+                <a:spcPts val="0"/>
+              </a:spcAft>
+              <a:buNone/>
+            </a:pPr>
+            <a:r>
+              <a:t/>
+            </a:r>
+            <a:endParaRPr>
+              <a:solidFill>
+                <a:srgbClr val="A64D79"/>
+              </a:solidFill>
+            </a:endParaRPr>
+          </a:p>
+        </p:txBody>
+      </p:sp>
+    </p:spTree>
+  </p:cSld>
+  <p:clrMapOvr>
+    <a:masterClrMapping/>
+  </p:clrMapOvr>
+</p:sld>
+</file>
+
+<file path=ppt/slides/slide11.xml><?xml version="1.0" encoding="utf-8"?>
+<p:sld xmlns:a="http://schemas.openxmlformats.org/drawingml/2006/main" xmlns:r="http://schemas.openxmlformats.org/officeDocument/2006/relationships" xmlns:mc="http://schemas.openxmlformats.org/markup-compatibility/2006" xmlns:mv="urn:schemas-microsoft-com:mac:vml" xmlns:p="http://schemas.openxmlformats.org/presentationml/2006/main" xmlns:c="http://schemas.openxmlformats.org/drawingml/2006/chart" xmlns:dgm="http://schemas.openxmlformats.org/drawingml/2006/diagram" xmlns:o="urn:schemas-microsoft-com:office:office" xmlns:v="urn:schemas-microsoft-com:vml" xmlns:pvml="urn:schemas-microsoft-com:office:powerpoint" xmlns:com="http://schemas.openxmlformats.org/drawingml/2006/compatibility" xmlns:p14="http://schemas.microsoft.com/office/powerpoint/2010/main" xmlns:p15="http://schemas.microsoft.com/office/powerpoint/2012/main" xmlns:ahyp="http://schemas.microsoft.com/office/drawing/2018/hyperlinkcolor">
+  <p:cSld>
+    <p:spTree>
+      <p:nvGrpSpPr>
+        <p:cNvPr id="150" name="Shape 150"/>
         <p:cNvGrpSpPr/>
         <p:nvPr/>
       </p:nvGrpSpPr>
@@ -6594,7 +8083,172 @@
       </p:grpSpPr>
       <p:sp>
         <p:nvSpPr>
-          <p:cNvPr id="120" name="Google Shape;120;p22"/>
+          <p:cNvPr id="151" name="Google Shape;151;p23"/>
+          <p:cNvSpPr txBox="1"/>
+          <p:nvPr>
+            <p:ph type="title"/>
+          </p:nvPr>
+        </p:nvSpPr>
+        <p:spPr>
+          <a:xfrm>
+            <a:off x="311700" y="126964"/>
+            <a:ext cx="8520600" cy="572700"/>
+          </a:xfrm>
+          <a:prstGeom prst="rect">
+            <a:avLst/>
+          </a:prstGeom>
+        </p:spPr>
+        <p:txBody>
+          <a:bodyPr anchorCtr="0" anchor="t" bIns="91425" lIns="91425" spcFirstLastPara="1" rIns="91425" wrap="square" tIns="91425">
+            <a:noAutofit/>
+          </a:bodyPr>
+          <a:lstStyle/>
+          <a:p>
+            <a:pPr indent="0" lvl="0" marL="0" rtl="0" algn="l">
+              <a:spcBef>
+                <a:spcPts val="0"/>
+              </a:spcBef>
+              <a:spcAft>
+                <a:spcPts val="0"/>
+              </a:spcAft>
+              <a:buNone/>
+            </a:pPr>
+            <a:r>
+              <a:rPr lang="en"/>
+              <a:t>Conclusões</a:t>
+            </a:r>
+            <a:endParaRPr/>
+          </a:p>
+        </p:txBody>
+      </p:sp>
+      <p:sp>
+        <p:nvSpPr>
+          <p:cNvPr id="152" name="Google Shape;152;p23"/>
+          <p:cNvSpPr txBox="1"/>
+          <p:nvPr>
+            <p:ph idx="1" type="body"/>
+          </p:nvPr>
+        </p:nvSpPr>
+        <p:spPr>
+          <a:xfrm>
+            <a:off x="453975" y="1067225"/>
+            <a:ext cx="7927800" cy="4076100"/>
+          </a:xfrm>
+          <a:prstGeom prst="rect">
+            <a:avLst/>
+          </a:prstGeom>
+        </p:spPr>
+        <p:txBody>
+          <a:bodyPr anchorCtr="0" anchor="t" bIns="91425" lIns="91425" spcFirstLastPara="1" rIns="91425" wrap="square" tIns="91425">
+            <a:noAutofit/>
+          </a:bodyPr>
+          <a:lstStyle/>
+          <a:p>
+            <a:pPr indent="-336550" lvl="0" marL="457200" rtl="0" algn="l">
+              <a:spcBef>
+                <a:spcPts val="0"/>
+              </a:spcBef>
+              <a:spcAft>
+                <a:spcPts val="0"/>
+              </a:spcAft>
+              <a:buSzPts val="1700"/>
+              <a:buChar char="●"/>
+            </a:pPr>
+            <a:r>
+              <a:rPr b="1" lang="en" sz="1700"/>
+              <a:t>Financiamento Fundeb </a:t>
+            </a:r>
+            <a:r>
+              <a:rPr lang="en" sz="1700"/>
+              <a:t>foi a variável de maior impacto no modelo, mas com coeficiente negativo, associado a municípios com maior financiamento e menor analfabetismo.</a:t>
+            </a:r>
+            <a:endParaRPr sz="1700"/>
+          </a:p>
+          <a:p>
+            <a:pPr indent="-336550" lvl="0" marL="457200" rtl="0" algn="l">
+              <a:spcBef>
+                <a:spcPts val="0"/>
+              </a:spcBef>
+              <a:spcAft>
+                <a:spcPts val="0"/>
+              </a:spcAft>
+              <a:buSzPts val="1700"/>
+              <a:buChar char="●"/>
+            </a:pPr>
+            <a:r>
+              <a:rPr lang="en" sz="1700"/>
+              <a:t>Retomamos a EDA para investigar o resultado, comparando financiamento Fundeb e atingimento das metas entre 2023 (treino) e 2024 (teste).</a:t>
+            </a:r>
+            <a:endParaRPr sz="1700"/>
+          </a:p>
+          <a:p>
+            <a:pPr indent="-336550" lvl="0" marL="457200" rtl="0" algn="l">
+              <a:spcBef>
+                <a:spcPts val="0"/>
+              </a:spcBef>
+              <a:spcAft>
+                <a:spcPts val="0"/>
+              </a:spcAft>
+              <a:buSzPts val="1700"/>
+              <a:buChar char="●"/>
+            </a:pPr>
+            <a:r>
+              <a:rPr b="1" lang="en" sz="1700"/>
+              <a:t>Alta variabilidade nas duas variáveis, </a:t>
+            </a:r>
+            <a:r>
+              <a:rPr lang="en" sz="1700"/>
+              <a:t>resultando em uma correlação muito baixa entre financiamento e atingimento da meta.</a:t>
+            </a:r>
+            <a:endParaRPr sz="1700"/>
+          </a:p>
+          <a:p>
+            <a:pPr indent="-336550" lvl="0" marL="457200" rtl="0" algn="l">
+              <a:spcBef>
+                <a:spcPts val="0"/>
+              </a:spcBef>
+              <a:spcAft>
+                <a:spcPts val="0"/>
+              </a:spcAft>
+              <a:buSzPts val="1700"/>
+              <a:buChar char="●"/>
+            </a:pPr>
+            <a:r>
+              <a:rPr lang="en" sz="1700"/>
+              <a:t>Concluímos que são necessárias mais variáveis, detalhando como o Fundeb é aplicado, e fatores socioeconômicos como infraestrutura, ensino, criminalidade e insegurança alimentar.</a:t>
+            </a:r>
+            <a:endParaRPr sz="1700"/>
+          </a:p>
+        </p:txBody>
+      </p:sp>
+    </p:spTree>
+  </p:cSld>
+  <p:clrMapOvr>
+    <a:masterClrMapping/>
+  </p:clrMapOvr>
+</p:sld>
+</file>
+
+<file path=ppt/slides/slide12.xml><?xml version="1.0" encoding="utf-8"?>
+<p:sld xmlns:a="http://schemas.openxmlformats.org/drawingml/2006/main" xmlns:r="http://schemas.openxmlformats.org/officeDocument/2006/relationships" xmlns:mc="http://schemas.openxmlformats.org/markup-compatibility/2006" xmlns:mv="urn:schemas-microsoft-com:mac:vml" xmlns:p="http://schemas.openxmlformats.org/presentationml/2006/main" xmlns:c="http://schemas.openxmlformats.org/drawingml/2006/chart" xmlns:dgm="http://schemas.openxmlformats.org/drawingml/2006/diagram" xmlns:o="urn:schemas-microsoft-com:office:office" xmlns:v="urn:schemas-microsoft-com:vml" xmlns:pvml="urn:schemas-microsoft-com:office:powerpoint" xmlns:com="http://schemas.openxmlformats.org/drawingml/2006/compatibility" xmlns:p14="http://schemas.microsoft.com/office/powerpoint/2010/main" xmlns:p15="http://schemas.microsoft.com/office/powerpoint/2012/main" xmlns:ahyp="http://schemas.microsoft.com/office/drawing/2018/hyperlinkcolor">
+  <p:cSld>
+    <p:spTree>
+      <p:nvGrpSpPr>
+        <p:cNvPr id="156" name="Shape 156"/>
+        <p:cNvGrpSpPr/>
+        <p:nvPr/>
+      </p:nvGrpSpPr>
+      <p:grpSpPr>
+        <a:xfrm>
+          <a:off x="0" y="0"/>
+          <a:ext cx="0" cy="0"/>
+          <a:chOff x="0" y="0"/>
+          <a:chExt cx="0" cy="0"/>
+        </a:xfrm>
+      </p:grpSpPr>
+      <p:sp>
+        <p:nvSpPr>
+          <p:cNvPr id="157" name="Google Shape;157;p24"/>
           <p:cNvSpPr txBox="1"/>
           <p:nvPr>
             <p:ph type="title"/>
@@ -8816,7 +10470,7 @@
         </p:nvSpPr>
         <p:spPr>
           <a:xfrm>
-            <a:off x="311700" y="126964"/>
+            <a:off x="311700" y="445025"/>
             <a:ext cx="8520600" cy="572700"/>
           </a:xfrm>
           <a:prstGeom prst="rect">
@@ -8840,7 +10494,7 @@
             </a:pPr>
             <a:r>
               <a:rPr lang="en"/>
-              <a:t>Conclusões</a:t>
+              <a:t>Fundeb: impacto negativo na Regressão Logística</a:t>
             </a:r>
             <a:endParaRPr/>
           </a:p>
@@ -8856,8 +10510,8 @@
         </p:nvSpPr>
         <p:spPr>
           <a:xfrm>
-            <a:off x="453975" y="1067225"/>
-            <a:ext cx="7927800" cy="4076100"/>
+            <a:off x="311700" y="1182926"/>
+            <a:ext cx="5609700" cy="1205700"/>
           </a:xfrm>
           <a:prstGeom prst="rect">
             <a:avLst/>
@@ -8869,80 +10523,1392 @@
           </a:bodyPr>
           <a:lstStyle/>
           <a:p>
-            <a:pPr indent="-336550" lvl="0" marL="457200" rtl="0" algn="l">
-              <a:spcBef>
-                <a:spcPts val="0"/>
-              </a:spcBef>
-              <a:spcAft>
-                <a:spcPts val="0"/>
-              </a:spcAft>
-              <a:buSzPts val="1700"/>
+            <a:pPr indent="-317500" lvl="0" marL="457200" rtl="0" algn="l">
+              <a:spcBef>
+                <a:spcPts val="0"/>
+              </a:spcBef>
+              <a:spcAft>
+                <a:spcPts val="0"/>
+              </a:spcAft>
+              <a:buSzPts val="1400"/>
               <a:buChar char="●"/>
             </a:pPr>
             <a:r>
-              <a:rPr b="1" lang="en" sz="1700"/>
-              <a:t>Financiamento Fundeb </a:t>
-            </a:r>
-            <a:r>
-              <a:rPr lang="en" sz="1700"/>
-              <a:t>foi a variável de maior impacto no modelo, mas com coeficiente negativo, associado a municípios com maior financiamento e menor analfabetismo.</a:t>
-            </a:r>
-            <a:endParaRPr sz="1700"/>
-          </a:p>
-          <a:p>
-            <a:pPr indent="-336550" lvl="0" marL="457200" rtl="0" algn="l">
-              <a:spcBef>
-                <a:spcPts val="0"/>
-              </a:spcBef>
-              <a:spcAft>
-                <a:spcPts val="0"/>
-              </a:spcAft>
-              <a:buSzPts val="1700"/>
+              <a:rPr lang="en" sz="1400"/>
+              <a:t>O coeficiente negativo do Fundeb na Regressão Logística nos chamou atenção e decidimos voltar à EDA para averiguar</a:t>
+            </a:r>
+            <a:endParaRPr sz="1400"/>
+          </a:p>
+          <a:p>
+            <a:pPr indent="-317500" lvl="0" marL="457200" rtl="0" algn="l">
+              <a:spcBef>
+                <a:spcPts val="0"/>
+              </a:spcBef>
+              <a:spcAft>
+                <a:spcPts val="0"/>
+              </a:spcAft>
+              <a:buSzPts val="1400"/>
               <a:buChar char="●"/>
             </a:pPr>
             <a:r>
-              <a:rPr lang="en" sz="1700"/>
-              <a:t>Retomamos a EDA para investigar o resultado, comparando financiamento Fundeb e atingimento das metas entre 2023 (treino) e 2024 (teste).</a:t>
-            </a:r>
-            <a:endParaRPr sz="1700"/>
-          </a:p>
-          <a:p>
-            <a:pPr indent="-336550" lvl="0" marL="457200" rtl="0" algn="l">
-              <a:spcBef>
-                <a:spcPts val="0"/>
-              </a:spcBef>
-              <a:spcAft>
-                <a:spcPts val="0"/>
-              </a:spcAft>
-              <a:buSzPts val="1700"/>
+              <a:rPr lang="en" sz="1400"/>
+              <a:t>Começamos com uma correlação direta entre Financiamento Fundeb (com ou sem as Complementações) e o Atingimento Meta (diferença entre a meta do município e a Alfab realizada)</a:t>
+            </a:r>
+            <a:endParaRPr sz="1400"/>
+          </a:p>
+        </p:txBody>
+      </p:sp>
+      <p:pic>
+        <p:nvPicPr>
+          <p:cNvPr id="116" name="Google Shape;116;p21"/>
+          <p:cNvPicPr preferRelativeResize="0"/>
+          <p:nvPr/>
+        </p:nvPicPr>
+        <p:blipFill rotWithShape="1">
+          <a:blip r:embed="rId3">
+            <a:alphaModFix/>
+          </a:blip>
+          <a:srcRect b="64526" l="0" r="0" t="0"/>
+          <a:stretch/>
+        </p:blipFill>
+        <p:spPr>
+          <a:xfrm>
+            <a:off x="6015625" y="1153900"/>
+            <a:ext cx="2936350" cy="790225"/>
+          </a:xfrm>
+          <a:prstGeom prst="rect">
+            <a:avLst/>
+          </a:prstGeom>
+          <a:noFill/>
+          <a:ln>
+            <a:noFill/>
+          </a:ln>
+        </p:spPr>
+      </p:pic>
+      <p:sp>
+        <p:nvSpPr>
+          <p:cNvPr id="117" name="Google Shape;117;p21"/>
+          <p:cNvSpPr txBox="1"/>
+          <p:nvPr>
+            <p:ph idx="1" type="body"/>
+          </p:nvPr>
+        </p:nvSpPr>
+        <p:spPr>
+          <a:xfrm>
+            <a:off x="302622" y="2405775"/>
+            <a:ext cx="8649300" cy="761100"/>
+          </a:xfrm>
+          <a:prstGeom prst="rect">
+            <a:avLst/>
+          </a:prstGeom>
+        </p:spPr>
+        <p:txBody>
+          <a:bodyPr anchorCtr="0" anchor="t" bIns="91425" lIns="91425" spcFirstLastPara="1" rIns="91425" wrap="square" tIns="91425">
+            <a:noAutofit/>
+          </a:bodyPr>
+          <a:lstStyle/>
+          <a:p>
+            <a:pPr indent="-317500" lvl="0" marL="457200" rtl="0" algn="l">
+              <a:spcBef>
+                <a:spcPts val="0"/>
+              </a:spcBef>
+              <a:spcAft>
+                <a:spcPts val="0"/>
+              </a:spcAft>
+              <a:buSzPts val="1400"/>
               <a:buChar char="●"/>
             </a:pPr>
             <a:r>
-              <a:rPr b="1" lang="en" sz="1700"/>
-              <a:t>Alta variabilidade nas duas variáveis, </a:t>
-            </a:r>
-            <a:r>
-              <a:rPr lang="en" sz="1700"/>
-              <a:t>resultando em uma correlação muito baixa entre financiamento e atingimento da meta.</a:t>
-            </a:r>
-            <a:endParaRPr sz="1700"/>
-          </a:p>
-          <a:p>
-            <a:pPr indent="-336550" lvl="0" marL="457200" rtl="0" algn="l">
-              <a:spcBef>
-                <a:spcPts val="0"/>
-              </a:spcBef>
-              <a:spcAft>
-                <a:spcPts val="0"/>
-              </a:spcAft>
-              <a:buSzPts val="1700"/>
+              <a:rPr lang="en" sz="1400"/>
+              <a:t>Essas variáveis têm correlação muito baixa, e ainda negativa (-0,14)</a:t>
+            </a:r>
+            <a:endParaRPr sz="1400"/>
+          </a:p>
+          <a:p>
+            <a:pPr indent="-317500" lvl="0" marL="457200" rtl="0" algn="l">
+              <a:spcBef>
+                <a:spcPts val="0"/>
+              </a:spcBef>
+              <a:spcAft>
+                <a:spcPts val="0"/>
+              </a:spcAft>
+              <a:buSzPts val="1400"/>
               <a:buChar char="●"/>
             </a:pPr>
             <a:r>
-              <a:rPr lang="en" sz="1700"/>
-              <a:t>Concluímos que são necessárias mais variáveis, detalhando como o Fundeb é aplicado, e fatores socioeconômicos como infraestrutura, ensino, criminalidade e insegurança alimentar.</a:t>
-            </a:r>
-            <a:endParaRPr sz="1700"/>
+              <a:rPr lang="en" sz="1400"/>
+              <a:t>Casos extremos nos 4 quadrantes:</a:t>
+            </a:r>
+            <a:endParaRPr sz="1400"/>
+          </a:p>
+        </p:txBody>
+      </p:sp>
+      <p:sp>
+        <p:nvSpPr>
+          <p:cNvPr id="118" name="Google Shape;118;p21"/>
+          <p:cNvSpPr/>
+          <p:nvPr/>
+        </p:nvSpPr>
+        <p:spPr>
+          <a:xfrm>
+            <a:off x="6246850" y="1403625"/>
+            <a:ext cx="1924200" cy="339300"/>
+          </a:xfrm>
+          <a:prstGeom prst="roundRect">
+            <a:avLst>
+              <a:gd fmla="val 16667" name="adj"/>
+            </a:avLst>
+          </a:prstGeom>
+          <a:noFill/>
+          <a:ln cap="flat" cmpd="sng" w="38100">
+            <a:solidFill>
+              <a:srgbClr val="FF0000"/>
+            </a:solidFill>
+            <a:prstDash val="solid"/>
+            <a:round/>
+            <a:headEnd len="sm" w="sm" type="none"/>
+            <a:tailEnd len="sm" w="sm" type="none"/>
+          </a:ln>
+        </p:spPr>
+        <p:txBody>
+          <a:bodyPr anchorCtr="0" anchor="ctr" bIns="91425" lIns="91425" spcFirstLastPara="1" rIns="91425" wrap="square" tIns="91425">
+            <a:noAutofit/>
+          </a:bodyPr>
+          <a:lstStyle/>
+          <a:p>
+            <a:pPr indent="0" lvl="0" marL="0" rtl="0" algn="ctr">
+              <a:spcBef>
+                <a:spcPts val="0"/>
+              </a:spcBef>
+              <a:spcAft>
+                <a:spcPts val="0"/>
+              </a:spcAft>
+              <a:buNone/>
+            </a:pPr>
+            <a:r>
+              <a:t/>
+            </a:r>
+            <a:endParaRPr/>
+          </a:p>
+        </p:txBody>
+      </p:sp>
+      <p:pic>
+        <p:nvPicPr>
+          <p:cNvPr id="119" name="Google Shape;119;p21" title="correl_fundeb_ating_metas.png"/>
+          <p:cNvPicPr preferRelativeResize="0"/>
+          <p:nvPr/>
+        </p:nvPicPr>
+        <p:blipFill>
+          <a:blip r:embed="rId4">
+            <a:alphaModFix/>
+          </a:blip>
+          <a:stretch>
+            <a:fillRect/>
+          </a:stretch>
+        </p:blipFill>
+        <p:spPr>
+          <a:xfrm>
+            <a:off x="5261948" y="2756036"/>
+            <a:ext cx="3690025" cy="2224750"/>
+          </a:xfrm>
+          <a:prstGeom prst="rect">
+            <a:avLst/>
+          </a:prstGeom>
+          <a:noFill/>
+          <a:ln>
+            <a:noFill/>
+          </a:ln>
+        </p:spPr>
+      </p:pic>
+      <p:graphicFrame>
+        <p:nvGraphicFramePr>
+          <p:cNvPr id="120" name="Google Shape;120;p21"/>
+          <p:cNvGraphicFramePr/>
+          <p:nvPr/>
+        </p:nvGraphicFramePr>
+        <p:xfrm>
+          <a:off x="598696" y="3085232"/>
+          <a:ext cx="3000000" cy="3000000"/>
+        </p:xfrm>
+        <a:graphic>
+          <a:graphicData uri="http://schemas.openxmlformats.org/drawingml/2006/table">
+            <a:tbl>
+              <a:tblPr>
+                <a:noFill/>
+                <a:tableStyleId>{02E23E79-4A31-47A8-8ED0-94E05C562DE2}</a:tableStyleId>
+              </a:tblPr>
+              <a:tblGrid>
+                <a:gridCol w="1572775"/>
+                <a:gridCol w="780550"/>
+                <a:gridCol w="734575"/>
+                <a:gridCol w="588800"/>
+                <a:gridCol w="559675"/>
+              </a:tblGrid>
+              <a:tr h="427400">
+                <a:tc>
+                  <a:txBody>
+                    <a:bodyPr/>
+                    <a:lstStyle/>
+                    <a:p>
+                      <a:pPr indent="0" lvl="0" marL="0" rtl="0" algn="ctr">
+                        <a:spcBef>
+                          <a:spcPts val="0"/>
+                        </a:spcBef>
+                        <a:spcAft>
+                          <a:spcPts val="0"/>
+                        </a:spcAft>
+                        <a:buNone/>
+                      </a:pPr>
+                      <a:r>
+                        <a:rPr lang="en" sz="900"/>
+                        <a:t>Cidade (pop)</a:t>
+                      </a:r>
+                      <a:endParaRPr sz="900"/>
+                    </a:p>
+                  </a:txBody>
+                  <a:tcPr marT="91425" marB="91425" marR="91425" marL="91425"/>
+                </a:tc>
+                <a:tc>
+                  <a:txBody>
+                    <a:bodyPr/>
+                    <a:lstStyle/>
+                    <a:p>
+                      <a:pPr indent="0" lvl="0" marL="0" rtl="0" algn="ctr">
+                        <a:spcBef>
+                          <a:spcPts val="0"/>
+                        </a:spcBef>
+                        <a:spcAft>
+                          <a:spcPts val="0"/>
+                        </a:spcAft>
+                        <a:buNone/>
+                      </a:pPr>
+                      <a:r>
+                        <a:rPr lang="en" sz="900"/>
+                        <a:t>Fundeb /aluno ‘23</a:t>
+                      </a:r>
+                      <a:endParaRPr sz="900"/>
+                    </a:p>
+                  </a:txBody>
+                  <a:tcPr marT="91425" marB="91425" marR="91425" marL="91425"/>
+                </a:tc>
+                <a:tc>
+                  <a:txBody>
+                    <a:bodyPr/>
+                    <a:lstStyle/>
+                    <a:p>
+                      <a:pPr indent="0" lvl="0" marL="0" rtl="0" algn="ctr">
+                        <a:spcBef>
+                          <a:spcPts val="0"/>
+                        </a:spcBef>
+                        <a:spcAft>
+                          <a:spcPts val="0"/>
+                        </a:spcAft>
+                        <a:buNone/>
+                      </a:pPr>
+                      <a:r>
+                        <a:rPr lang="en" sz="900"/>
+                        <a:t>Meta ‘23 %</a:t>
+                      </a:r>
+                      <a:endParaRPr sz="900"/>
+                    </a:p>
+                  </a:txBody>
+                  <a:tcPr marT="91425" marB="91425" marR="91425" marL="91425"/>
+                </a:tc>
+                <a:tc>
+                  <a:txBody>
+                    <a:bodyPr/>
+                    <a:lstStyle/>
+                    <a:p>
+                      <a:pPr indent="0" lvl="0" marL="0" rtl="0" algn="ctr">
+                        <a:spcBef>
+                          <a:spcPts val="0"/>
+                        </a:spcBef>
+                        <a:spcAft>
+                          <a:spcPts val="0"/>
+                        </a:spcAft>
+                        <a:buNone/>
+                      </a:pPr>
+                      <a:r>
+                        <a:rPr lang="en" sz="900"/>
+                        <a:t>Alfab</a:t>
+                      </a:r>
+                      <a:endParaRPr sz="900"/>
+                    </a:p>
+                    <a:p>
+                      <a:pPr indent="0" lvl="0" marL="0" rtl="0" algn="ctr">
+                        <a:spcBef>
+                          <a:spcPts val="0"/>
+                        </a:spcBef>
+                        <a:spcAft>
+                          <a:spcPts val="0"/>
+                        </a:spcAft>
+                        <a:buNone/>
+                      </a:pPr>
+                      <a:r>
+                        <a:rPr lang="en" sz="900"/>
+                        <a:t>%</a:t>
+                      </a:r>
+                      <a:endParaRPr sz="900"/>
+                    </a:p>
+                  </a:txBody>
+                  <a:tcPr marT="91425" marB="91425" marR="91425" marL="91425"/>
+                </a:tc>
+                <a:tc>
+                  <a:txBody>
+                    <a:bodyPr/>
+                    <a:lstStyle/>
+                    <a:p>
+                      <a:pPr indent="0" lvl="0" marL="0" rtl="0" algn="ctr">
+                        <a:spcBef>
+                          <a:spcPts val="0"/>
+                        </a:spcBef>
+                        <a:spcAft>
+                          <a:spcPts val="0"/>
+                        </a:spcAft>
+                        <a:buNone/>
+                      </a:pPr>
+                      <a:r>
+                        <a:rPr lang="en" sz="900"/>
+                        <a:t>Ating.</a:t>
+                      </a:r>
+                      <a:endParaRPr sz="900"/>
+                    </a:p>
+                    <a:p>
+                      <a:pPr indent="0" lvl="0" marL="0" rtl="0" algn="ctr">
+                        <a:spcBef>
+                          <a:spcPts val="0"/>
+                        </a:spcBef>
+                        <a:spcAft>
+                          <a:spcPts val="0"/>
+                        </a:spcAft>
+                        <a:buNone/>
+                      </a:pPr>
+                      <a:r>
+                        <a:rPr lang="en" sz="900"/>
+                        <a:t>(pp)</a:t>
+                      </a:r>
+                      <a:endParaRPr sz="900"/>
+                    </a:p>
+                  </a:txBody>
+                  <a:tcPr marT="91425" marB="91425" marR="91425" marL="91425"/>
+                </a:tc>
+              </a:tr>
+              <a:tr h="345775">
+                <a:tc>
+                  <a:txBody>
+                    <a:bodyPr/>
+                    <a:lstStyle/>
+                    <a:p>
+                      <a:pPr indent="0" lvl="0" marL="0" rtl="0" algn="ctr">
+                        <a:spcBef>
+                          <a:spcPts val="0"/>
+                        </a:spcBef>
+                        <a:spcAft>
+                          <a:spcPts val="0"/>
+                        </a:spcAft>
+                        <a:buNone/>
+                      </a:pPr>
+                      <a:r>
+                        <a:rPr lang="en" sz="900"/>
+                        <a:t>Coruripe/AL (50k)</a:t>
+                      </a:r>
+                      <a:endParaRPr sz="900"/>
+                    </a:p>
+                  </a:txBody>
+                  <a:tcPr marT="91425" marB="91425" marR="91425" marL="91425"/>
+                </a:tc>
+                <a:tc>
+                  <a:txBody>
+                    <a:bodyPr/>
+                    <a:lstStyle/>
+                    <a:p>
+                      <a:pPr indent="0" lvl="0" marL="0" rtl="0" algn="ctr">
+                        <a:spcBef>
+                          <a:spcPts val="0"/>
+                        </a:spcBef>
+                        <a:spcAft>
+                          <a:spcPts val="0"/>
+                        </a:spcAft>
+                        <a:buNone/>
+                      </a:pPr>
+                      <a:r>
+                        <a:rPr b="1" lang="en" sz="900">
+                          <a:solidFill>
+                            <a:srgbClr val="0000FF"/>
+                          </a:solidFill>
+                        </a:rPr>
+                        <a:t>111k</a:t>
+                      </a:r>
+                      <a:endParaRPr b="1" sz="900">
+                        <a:solidFill>
+                          <a:srgbClr val="0000FF"/>
+                        </a:solidFill>
+                      </a:endParaRPr>
+                    </a:p>
+                  </a:txBody>
+                  <a:tcPr marT="91425" marB="91425" marR="91425" marL="91425"/>
+                </a:tc>
+                <a:tc>
+                  <a:txBody>
+                    <a:bodyPr/>
+                    <a:lstStyle/>
+                    <a:p>
+                      <a:pPr indent="0" lvl="0" marL="0" rtl="0" algn="ctr">
+                        <a:spcBef>
+                          <a:spcPts val="0"/>
+                        </a:spcBef>
+                        <a:spcAft>
+                          <a:spcPts val="0"/>
+                        </a:spcAft>
+                        <a:buNone/>
+                      </a:pPr>
+                      <a:r>
+                        <a:rPr lang="en" sz="900"/>
+                        <a:t>80%</a:t>
+                      </a:r>
+                      <a:endParaRPr sz="900"/>
+                    </a:p>
+                  </a:txBody>
+                  <a:tcPr marT="91425" marB="91425" marR="91425" marL="91425"/>
+                </a:tc>
+                <a:tc>
+                  <a:txBody>
+                    <a:bodyPr/>
+                    <a:lstStyle/>
+                    <a:p>
+                      <a:pPr indent="0" lvl="0" marL="0" rtl="0" algn="ctr">
+                        <a:spcBef>
+                          <a:spcPts val="0"/>
+                        </a:spcBef>
+                        <a:spcAft>
+                          <a:spcPts val="0"/>
+                        </a:spcAft>
+                        <a:buNone/>
+                      </a:pPr>
+                      <a:r>
+                        <a:rPr lang="en" sz="900"/>
+                        <a:t>94%</a:t>
+                      </a:r>
+                      <a:endParaRPr sz="900"/>
+                    </a:p>
+                  </a:txBody>
+                  <a:tcPr marT="91425" marB="91425" marR="91425" marL="91425"/>
+                </a:tc>
+                <a:tc>
+                  <a:txBody>
+                    <a:bodyPr/>
+                    <a:lstStyle/>
+                    <a:p>
+                      <a:pPr indent="0" lvl="0" marL="0" rtl="0" algn="ctr">
+                        <a:spcBef>
+                          <a:spcPts val="0"/>
+                        </a:spcBef>
+                        <a:spcAft>
+                          <a:spcPts val="0"/>
+                        </a:spcAft>
+                        <a:buNone/>
+                      </a:pPr>
+                      <a:r>
+                        <a:rPr b="1" lang="en" sz="900">
+                          <a:solidFill>
+                            <a:srgbClr val="0000FF"/>
+                          </a:solidFill>
+                        </a:rPr>
+                        <a:t>+14</a:t>
+                      </a:r>
+                      <a:endParaRPr b="1" sz="900">
+                        <a:solidFill>
+                          <a:srgbClr val="0000FF"/>
+                        </a:solidFill>
+                      </a:endParaRPr>
+                    </a:p>
+                  </a:txBody>
+                  <a:tcPr marT="91425" marB="91425" marR="91425" marL="91425"/>
+                </a:tc>
+              </a:tr>
+              <a:tr h="146200">
+                <a:tc>
+                  <a:txBody>
+                    <a:bodyPr/>
+                    <a:lstStyle/>
+                    <a:p>
+                      <a:pPr indent="0" lvl="0" marL="0" rtl="0" algn="ctr">
+                        <a:spcBef>
+                          <a:spcPts val="0"/>
+                        </a:spcBef>
+                        <a:spcAft>
+                          <a:spcPts val="0"/>
+                        </a:spcAft>
+                        <a:buNone/>
+                      </a:pPr>
+                      <a:r>
+                        <a:rPr lang="en" sz="900"/>
+                        <a:t>Januária/MG (65k)</a:t>
+                      </a:r>
+                      <a:endParaRPr sz="900"/>
+                    </a:p>
+                  </a:txBody>
+                  <a:tcPr marT="91425" marB="91425" marR="91425" marL="91425"/>
+                </a:tc>
+                <a:tc>
+                  <a:txBody>
+                    <a:bodyPr/>
+                    <a:lstStyle/>
+                    <a:p>
+                      <a:pPr indent="0" lvl="0" marL="0" rtl="0" algn="ctr">
+                        <a:spcBef>
+                          <a:spcPts val="0"/>
+                        </a:spcBef>
+                        <a:spcAft>
+                          <a:spcPts val="0"/>
+                        </a:spcAft>
+                        <a:buNone/>
+                      </a:pPr>
+                      <a:r>
+                        <a:rPr b="1" lang="en" sz="900">
+                          <a:solidFill>
+                            <a:srgbClr val="FF0000"/>
+                          </a:solidFill>
+                        </a:rPr>
+                        <a:t>60k</a:t>
+                      </a:r>
+                      <a:endParaRPr b="1" sz="900">
+                        <a:solidFill>
+                          <a:srgbClr val="FF0000"/>
+                        </a:solidFill>
+                      </a:endParaRPr>
+                    </a:p>
+                  </a:txBody>
+                  <a:tcPr marT="91425" marB="91425" marR="91425" marL="91425"/>
+                </a:tc>
+                <a:tc>
+                  <a:txBody>
+                    <a:bodyPr/>
+                    <a:lstStyle/>
+                    <a:p>
+                      <a:pPr indent="0" lvl="0" marL="0" rtl="0" algn="ctr">
+                        <a:spcBef>
+                          <a:spcPts val="0"/>
+                        </a:spcBef>
+                        <a:spcAft>
+                          <a:spcPts val="0"/>
+                        </a:spcAft>
+                        <a:buNone/>
+                      </a:pPr>
+                      <a:r>
+                        <a:rPr lang="en" sz="900"/>
+                        <a:t>35%</a:t>
+                      </a:r>
+                      <a:endParaRPr sz="900"/>
+                    </a:p>
+                  </a:txBody>
+                  <a:tcPr marT="91425" marB="91425" marR="91425" marL="91425"/>
+                </a:tc>
+                <a:tc>
+                  <a:txBody>
+                    <a:bodyPr/>
+                    <a:lstStyle/>
+                    <a:p>
+                      <a:pPr indent="0" lvl="0" marL="0" rtl="0" algn="ctr">
+                        <a:spcBef>
+                          <a:spcPts val="0"/>
+                        </a:spcBef>
+                        <a:spcAft>
+                          <a:spcPts val="0"/>
+                        </a:spcAft>
+                        <a:buNone/>
+                      </a:pPr>
+                      <a:r>
+                        <a:rPr lang="en" sz="900"/>
+                        <a:t>40%</a:t>
+                      </a:r>
+                      <a:endParaRPr sz="900"/>
+                    </a:p>
+                  </a:txBody>
+                  <a:tcPr marT="91425" marB="91425" marR="91425" marL="91425"/>
+                </a:tc>
+                <a:tc>
+                  <a:txBody>
+                    <a:bodyPr/>
+                    <a:lstStyle/>
+                    <a:p>
+                      <a:pPr indent="0" lvl="0" marL="0" rtl="0" algn="ctr">
+                        <a:spcBef>
+                          <a:spcPts val="0"/>
+                        </a:spcBef>
+                        <a:spcAft>
+                          <a:spcPts val="0"/>
+                        </a:spcAft>
+                        <a:buNone/>
+                      </a:pPr>
+                      <a:r>
+                        <a:rPr b="1" lang="en" sz="900">
+                          <a:solidFill>
+                            <a:srgbClr val="0000FF"/>
+                          </a:solidFill>
+                        </a:rPr>
+                        <a:t>+5</a:t>
+                      </a:r>
+                      <a:endParaRPr b="1" sz="900">
+                        <a:solidFill>
+                          <a:srgbClr val="0000FF"/>
+                        </a:solidFill>
+                      </a:endParaRPr>
+                    </a:p>
+                  </a:txBody>
+                  <a:tcPr marT="91425" marB="91425" marR="91425" marL="91425"/>
+                </a:tc>
+              </a:tr>
+              <a:tr h="100850">
+                <a:tc>
+                  <a:txBody>
+                    <a:bodyPr/>
+                    <a:lstStyle/>
+                    <a:p>
+                      <a:pPr indent="0" lvl="0" marL="0" rtl="0" algn="ctr">
+                        <a:spcBef>
+                          <a:spcPts val="0"/>
+                        </a:spcBef>
+                        <a:spcAft>
+                          <a:spcPts val="0"/>
+                        </a:spcAft>
+                        <a:buNone/>
+                      </a:pPr>
+                      <a:r>
+                        <a:rPr lang="en" sz="900"/>
+                        <a:t>Serrinha/BA (80k)</a:t>
+                      </a:r>
+                      <a:endParaRPr sz="900"/>
+                    </a:p>
+                  </a:txBody>
+                  <a:tcPr marT="91425" marB="91425" marR="91425" marL="91425"/>
+                </a:tc>
+                <a:tc>
+                  <a:txBody>
+                    <a:bodyPr/>
+                    <a:lstStyle/>
+                    <a:p>
+                      <a:pPr indent="0" lvl="0" marL="0" rtl="0" algn="ctr">
+                        <a:spcBef>
+                          <a:spcPts val="0"/>
+                        </a:spcBef>
+                        <a:spcAft>
+                          <a:spcPts val="0"/>
+                        </a:spcAft>
+                        <a:buNone/>
+                      </a:pPr>
+                      <a:r>
+                        <a:rPr b="1" lang="en" sz="900">
+                          <a:solidFill>
+                            <a:srgbClr val="0000FF"/>
+                          </a:solidFill>
+                        </a:rPr>
+                        <a:t>185k</a:t>
+                      </a:r>
+                      <a:endParaRPr b="1" sz="900">
+                        <a:solidFill>
+                          <a:srgbClr val="0000FF"/>
+                        </a:solidFill>
+                      </a:endParaRPr>
+                    </a:p>
+                  </a:txBody>
+                  <a:tcPr marT="91425" marB="91425" marR="91425" marL="91425"/>
+                </a:tc>
+                <a:tc>
+                  <a:txBody>
+                    <a:bodyPr/>
+                    <a:lstStyle/>
+                    <a:p>
+                      <a:pPr indent="0" lvl="0" marL="0" rtl="0" algn="ctr">
+                        <a:spcBef>
+                          <a:spcPts val="0"/>
+                        </a:spcBef>
+                        <a:spcAft>
+                          <a:spcPts val="0"/>
+                        </a:spcAft>
+                        <a:buNone/>
+                      </a:pPr>
+                      <a:r>
+                        <a:rPr lang="en" sz="900"/>
+                        <a:t>41%</a:t>
+                      </a:r>
+                      <a:endParaRPr sz="900"/>
+                    </a:p>
+                  </a:txBody>
+                  <a:tcPr marT="91425" marB="91425" marR="91425" marL="91425"/>
+                </a:tc>
+                <a:tc>
+                  <a:txBody>
+                    <a:bodyPr/>
+                    <a:lstStyle/>
+                    <a:p>
+                      <a:pPr indent="0" lvl="0" marL="0" rtl="0" algn="ctr">
+                        <a:spcBef>
+                          <a:spcPts val="0"/>
+                        </a:spcBef>
+                        <a:spcAft>
+                          <a:spcPts val="0"/>
+                        </a:spcAft>
+                        <a:buNone/>
+                      </a:pPr>
+                      <a:r>
+                        <a:rPr lang="en" sz="900"/>
+                        <a:t>26%</a:t>
+                      </a:r>
+                      <a:endParaRPr sz="900"/>
+                    </a:p>
+                  </a:txBody>
+                  <a:tcPr marT="91425" marB="91425" marR="91425" marL="91425"/>
+                </a:tc>
+                <a:tc>
+                  <a:txBody>
+                    <a:bodyPr/>
+                    <a:lstStyle/>
+                    <a:p>
+                      <a:pPr indent="0" lvl="0" marL="0" rtl="0" algn="ctr">
+                        <a:spcBef>
+                          <a:spcPts val="0"/>
+                        </a:spcBef>
+                        <a:spcAft>
+                          <a:spcPts val="0"/>
+                        </a:spcAft>
+                        <a:buNone/>
+                      </a:pPr>
+                      <a:r>
+                        <a:rPr b="1" lang="en" sz="900">
+                          <a:solidFill>
+                            <a:srgbClr val="FF0000"/>
+                          </a:solidFill>
+                        </a:rPr>
+                        <a:t>-15</a:t>
+                      </a:r>
+                      <a:endParaRPr b="1" sz="900">
+                        <a:solidFill>
+                          <a:srgbClr val="FF0000"/>
+                        </a:solidFill>
+                      </a:endParaRPr>
+                    </a:p>
+                  </a:txBody>
+                  <a:tcPr marT="91425" marB="91425" marR="91425" marL="91425"/>
+                </a:tc>
+              </a:tr>
+              <a:tr h="236900">
+                <a:tc>
+                  <a:txBody>
+                    <a:bodyPr/>
+                    <a:lstStyle/>
+                    <a:p>
+                      <a:pPr indent="0" lvl="0" marL="0" rtl="0" algn="ctr">
+                        <a:spcBef>
+                          <a:spcPts val="0"/>
+                        </a:spcBef>
+                        <a:spcAft>
+                          <a:spcPts val="0"/>
+                        </a:spcAft>
+                        <a:buNone/>
+                      </a:pPr>
+                      <a:r>
+                        <a:rPr lang="en" sz="900"/>
+                        <a:t>Maceió/AL </a:t>
+                      </a:r>
+                      <a:r>
+                        <a:rPr b="1" lang="en" sz="900"/>
+                        <a:t>(957k)</a:t>
+                      </a:r>
+                      <a:endParaRPr b="1" sz="900"/>
+                    </a:p>
+                  </a:txBody>
+                  <a:tcPr marT="91425" marB="91425" marR="91425" marL="91425"/>
+                </a:tc>
+                <a:tc>
+                  <a:txBody>
+                    <a:bodyPr/>
+                    <a:lstStyle/>
+                    <a:p>
+                      <a:pPr indent="0" lvl="0" marL="0" rtl="0" algn="ctr">
+                        <a:spcBef>
+                          <a:spcPts val="0"/>
+                        </a:spcBef>
+                        <a:spcAft>
+                          <a:spcPts val="0"/>
+                        </a:spcAft>
+                        <a:buNone/>
+                      </a:pPr>
+                      <a:r>
+                        <a:rPr b="1" lang="en" sz="900">
+                          <a:solidFill>
+                            <a:srgbClr val="FF0000"/>
+                          </a:solidFill>
+                        </a:rPr>
+                        <a:t>57k</a:t>
+                      </a:r>
+                      <a:endParaRPr b="1" sz="900">
+                        <a:solidFill>
+                          <a:srgbClr val="FF0000"/>
+                        </a:solidFill>
+                      </a:endParaRPr>
+                    </a:p>
+                  </a:txBody>
+                  <a:tcPr marT="91425" marB="91425" marR="91425" marL="91425"/>
+                </a:tc>
+                <a:tc>
+                  <a:txBody>
+                    <a:bodyPr/>
+                    <a:lstStyle/>
+                    <a:p>
+                      <a:pPr indent="0" lvl="0" marL="0" rtl="0" algn="ctr">
+                        <a:spcBef>
+                          <a:spcPts val="0"/>
+                        </a:spcBef>
+                        <a:spcAft>
+                          <a:spcPts val="0"/>
+                        </a:spcAft>
+                        <a:buNone/>
+                      </a:pPr>
+                      <a:r>
+                        <a:rPr lang="en" sz="900"/>
+                        <a:t>52%</a:t>
+                      </a:r>
+                      <a:endParaRPr sz="900"/>
+                    </a:p>
+                  </a:txBody>
+                  <a:tcPr marT="91425" marB="91425" marR="91425" marL="91425"/>
+                </a:tc>
+                <a:tc>
+                  <a:txBody>
+                    <a:bodyPr/>
+                    <a:lstStyle/>
+                    <a:p>
+                      <a:pPr indent="0" lvl="0" marL="0" rtl="0" algn="ctr">
+                        <a:spcBef>
+                          <a:spcPts val="0"/>
+                        </a:spcBef>
+                        <a:spcAft>
+                          <a:spcPts val="0"/>
+                        </a:spcAft>
+                        <a:buNone/>
+                      </a:pPr>
+                      <a:r>
+                        <a:rPr lang="en" sz="900"/>
+                        <a:t>39%</a:t>
+                      </a:r>
+                      <a:endParaRPr sz="900"/>
+                    </a:p>
+                  </a:txBody>
+                  <a:tcPr marT="91425" marB="91425" marR="91425" marL="91425"/>
+                </a:tc>
+                <a:tc>
+                  <a:txBody>
+                    <a:bodyPr/>
+                    <a:lstStyle/>
+                    <a:p>
+                      <a:pPr indent="0" lvl="0" marL="0" rtl="0" algn="ctr">
+                        <a:spcBef>
+                          <a:spcPts val="0"/>
+                        </a:spcBef>
+                        <a:spcAft>
+                          <a:spcPts val="0"/>
+                        </a:spcAft>
+                        <a:buNone/>
+                      </a:pPr>
+                      <a:r>
+                        <a:rPr b="1" lang="en" sz="900">
+                          <a:solidFill>
+                            <a:srgbClr val="FF0000"/>
+                          </a:solidFill>
+                        </a:rPr>
+                        <a:t>-13</a:t>
+                      </a:r>
+                      <a:endParaRPr b="1" sz="900">
+                        <a:solidFill>
+                          <a:srgbClr val="FF0000"/>
+                        </a:solidFill>
+                      </a:endParaRPr>
+                    </a:p>
+                  </a:txBody>
+                  <a:tcPr marT="91425" marB="91425" marR="91425" marL="91425"/>
+                </a:tc>
+              </a:tr>
+            </a:tbl>
+          </a:graphicData>
+        </a:graphic>
+      </p:graphicFrame>
+      <p:sp>
+        <p:nvSpPr>
+          <p:cNvPr id="121" name="Google Shape;121;p21"/>
+          <p:cNvSpPr/>
+          <p:nvPr/>
+        </p:nvSpPr>
+        <p:spPr>
+          <a:xfrm>
+            <a:off x="6304384" y="3295800"/>
+            <a:ext cx="120300" cy="121500"/>
+          </a:xfrm>
+          <a:prstGeom prst="ellipse">
+            <a:avLst/>
+          </a:prstGeom>
+          <a:solidFill>
+            <a:srgbClr val="00FF00"/>
+          </a:solidFill>
+          <a:ln cap="flat" cmpd="sng" w="9525">
+            <a:solidFill>
+              <a:schemeClr val="dk2"/>
+            </a:solidFill>
+            <a:prstDash val="solid"/>
+            <a:round/>
+            <a:headEnd len="sm" w="sm" type="none"/>
+            <a:tailEnd len="sm" w="sm" type="none"/>
+          </a:ln>
+        </p:spPr>
+        <p:txBody>
+          <a:bodyPr anchorCtr="0" anchor="ctr" bIns="91425" lIns="91425" spcFirstLastPara="1" rIns="91425" wrap="square" tIns="91425">
+            <a:noAutofit/>
+          </a:bodyPr>
+          <a:lstStyle/>
+          <a:p>
+            <a:pPr indent="0" lvl="0" marL="0" rtl="0" algn="ctr">
+              <a:spcBef>
+                <a:spcPts val="0"/>
+              </a:spcBef>
+              <a:spcAft>
+                <a:spcPts val="0"/>
+              </a:spcAft>
+              <a:buNone/>
+            </a:pPr>
+            <a:r>
+              <a:t/>
+            </a:r>
+            <a:endParaRPr/>
+          </a:p>
+        </p:txBody>
+      </p:sp>
+      <p:sp>
+        <p:nvSpPr>
+          <p:cNvPr id="122" name="Google Shape;122;p21"/>
+          <p:cNvSpPr/>
+          <p:nvPr/>
+        </p:nvSpPr>
+        <p:spPr>
+          <a:xfrm>
+            <a:off x="5798344" y="3595230"/>
+            <a:ext cx="120300" cy="121500"/>
+          </a:xfrm>
+          <a:prstGeom prst="ellipse">
+            <a:avLst/>
+          </a:prstGeom>
+          <a:solidFill>
+            <a:srgbClr val="6AA84F"/>
+          </a:solidFill>
+          <a:ln cap="flat" cmpd="sng" w="9525">
+            <a:solidFill>
+              <a:schemeClr val="dk2"/>
+            </a:solidFill>
+            <a:prstDash val="solid"/>
+            <a:round/>
+            <a:headEnd len="sm" w="sm" type="none"/>
+            <a:tailEnd len="sm" w="sm" type="none"/>
+          </a:ln>
+        </p:spPr>
+        <p:txBody>
+          <a:bodyPr anchorCtr="0" anchor="ctr" bIns="91425" lIns="91425" spcFirstLastPara="1" rIns="91425" wrap="square" tIns="91425">
+            <a:noAutofit/>
+          </a:bodyPr>
+          <a:lstStyle/>
+          <a:p>
+            <a:pPr indent="0" lvl="0" marL="0" rtl="0" algn="ctr">
+              <a:spcBef>
+                <a:spcPts val="0"/>
+              </a:spcBef>
+              <a:spcAft>
+                <a:spcPts val="0"/>
+              </a:spcAft>
+              <a:buNone/>
+            </a:pPr>
+            <a:r>
+              <a:t/>
+            </a:r>
+            <a:endParaRPr/>
+          </a:p>
+        </p:txBody>
+      </p:sp>
+      <p:sp>
+        <p:nvSpPr>
+          <p:cNvPr id="123" name="Google Shape;123;p21"/>
+          <p:cNvSpPr/>
+          <p:nvPr/>
+        </p:nvSpPr>
+        <p:spPr>
+          <a:xfrm>
+            <a:off x="776458" y="4634653"/>
+            <a:ext cx="120300" cy="121500"/>
+          </a:xfrm>
+          <a:prstGeom prst="ellipse">
+            <a:avLst/>
+          </a:prstGeom>
+          <a:solidFill>
+            <a:srgbClr val="FF0000"/>
+          </a:solidFill>
+          <a:ln cap="flat" cmpd="sng" w="9525">
+            <a:solidFill>
+              <a:schemeClr val="dk2"/>
+            </a:solidFill>
+            <a:prstDash val="solid"/>
+            <a:round/>
+            <a:headEnd len="sm" w="sm" type="none"/>
+            <a:tailEnd len="sm" w="sm" type="none"/>
+          </a:ln>
+        </p:spPr>
+        <p:txBody>
+          <a:bodyPr anchorCtr="0" anchor="ctr" bIns="91425" lIns="91425" spcFirstLastPara="1" rIns="91425" wrap="square" tIns="91425">
+            <a:noAutofit/>
+          </a:bodyPr>
+          <a:lstStyle/>
+          <a:p>
+            <a:pPr indent="0" lvl="0" marL="0" rtl="0" algn="ctr">
+              <a:spcBef>
+                <a:spcPts val="0"/>
+              </a:spcBef>
+              <a:spcAft>
+                <a:spcPts val="0"/>
+              </a:spcAft>
+              <a:buNone/>
+            </a:pPr>
+            <a:r>
+              <a:t/>
+            </a:r>
+            <a:endParaRPr/>
+          </a:p>
+        </p:txBody>
+      </p:sp>
+      <p:sp>
+        <p:nvSpPr>
+          <p:cNvPr id="124" name="Google Shape;124;p21"/>
+          <p:cNvSpPr/>
+          <p:nvPr/>
+        </p:nvSpPr>
+        <p:spPr>
+          <a:xfrm>
+            <a:off x="771052" y="4315820"/>
+            <a:ext cx="120300" cy="121500"/>
+          </a:xfrm>
+          <a:prstGeom prst="ellipse">
+            <a:avLst/>
+          </a:prstGeom>
+          <a:solidFill>
+            <a:srgbClr val="980000"/>
+          </a:solidFill>
+          <a:ln cap="flat" cmpd="sng" w="9525">
+            <a:solidFill>
+              <a:schemeClr val="dk2"/>
+            </a:solidFill>
+            <a:prstDash val="solid"/>
+            <a:round/>
+            <a:headEnd len="sm" w="sm" type="none"/>
+            <a:tailEnd len="sm" w="sm" type="none"/>
+          </a:ln>
+        </p:spPr>
+        <p:txBody>
+          <a:bodyPr anchorCtr="0" anchor="ctr" bIns="91425" lIns="91425" spcFirstLastPara="1" rIns="91425" wrap="square" tIns="91425">
+            <a:noAutofit/>
+          </a:bodyPr>
+          <a:lstStyle/>
+          <a:p>
+            <a:pPr indent="0" lvl="0" marL="0" rtl="0" algn="ctr">
+              <a:spcBef>
+                <a:spcPts val="0"/>
+              </a:spcBef>
+              <a:spcAft>
+                <a:spcPts val="0"/>
+              </a:spcAft>
+              <a:buNone/>
+            </a:pPr>
+            <a:r>
+              <a:t/>
+            </a:r>
+            <a:endParaRPr/>
+          </a:p>
+        </p:txBody>
+      </p:sp>
+      <p:sp>
+        <p:nvSpPr>
+          <p:cNvPr id="125" name="Google Shape;125;p21"/>
+          <p:cNvSpPr/>
+          <p:nvPr/>
+        </p:nvSpPr>
+        <p:spPr>
+          <a:xfrm>
+            <a:off x="772934" y="3638971"/>
+            <a:ext cx="120300" cy="121500"/>
+          </a:xfrm>
+          <a:prstGeom prst="ellipse">
+            <a:avLst/>
+          </a:prstGeom>
+          <a:solidFill>
+            <a:srgbClr val="00FF00"/>
+          </a:solidFill>
+          <a:ln cap="flat" cmpd="sng" w="9525">
+            <a:solidFill>
+              <a:schemeClr val="dk2"/>
+            </a:solidFill>
+            <a:prstDash val="solid"/>
+            <a:round/>
+            <a:headEnd len="sm" w="sm" type="none"/>
+            <a:tailEnd len="sm" w="sm" type="none"/>
+          </a:ln>
+        </p:spPr>
+        <p:txBody>
+          <a:bodyPr anchorCtr="0" anchor="ctr" bIns="91425" lIns="91425" spcFirstLastPara="1" rIns="91425" wrap="square" tIns="91425">
+            <a:noAutofit/>
+          </a:bodyPr>
+          <a:lstStyle/>
+          <a:p>
+            <a:pPr indent="0" lvl="0" marL="0" rtl="0" algn="ctr">
+              <a:spcBef>
+                <a:spcPts val="0"/>
+              </a:spcBef>
+              <a:spcAft>
+                <a:spcPts val="0"/>
+              </a:spcAft>
+              <a:buNone/>
+            </a:pPr>
+            <a:r>
+              <a:t/>
+            </a:r>
+            <a:endParaRPr/>
+          </a:p>
+        </p:txBody>
+      </p:sp>
+      <p:sp>
+        <p:nvSpPr>
+          <p:cNvPr id="126" name="Google Shape;126;p21"/>
+          <p:cNvSpPr/>
+          <p:nvPr/>
+        </p:nvSpPr>
+        <p:spPr>
+          <a:xfrm>
+            <a:off x="765227" y="3983923"/>
+            <a:ext cx="120300" cy="121500"/>
+          </a:xfrm>
+          <a:prstGeom prst="ellipse">
+            <a:avLst/>
+          </a:prstGeom>
+          <a:solidFill>
+            <a:srgbClr val="6AA84F"/>
+          </a:solidFill>
+          <a:ln cap="flat" cmpd="sng" w="9525">
+            <a:solidFill>
+              <a:schemeClr val="dk2"/>
+            </a:solidFill>
+            <a:prstDash val="solid"/>
+            <a:round/>
+            <a:headEnd len="sm" w="sm" type="none"/>
+            <a:tailEnd len="sm" w="sm" type="none"/>
+          </a:ln>
+        </p:spPr>
+        <p:txBody>
+          <a:bodyPr anchorCtr="0" anchor="ctr" bIns="91425" lIns="91425" spcFirstLastPara="1" rIns="91425" wrap="square" tIns="91425">
+            <a:noAutofit/>
+          </a:bodyPr>
+          <a:lstStyle/>
+          <a:p>
+            <a:pPr indent="0" lvl="0" marL="0" rtl="0" algn="ctr">
+              <a:spcBef>
+                <a:spcPts val="0"/>
+              </a:spcBef>
+              <a:spcAft>
+                <a:spcPts val="0"/>
+              </a:spcAft>
+              <a:buNone/>
+            </a:pPr>
+            <a:r>
+              <a:t/>
+            </a:r>
+            <a:endParaRPr/>
+          </a:p>
+        </p:txBody>
+      </p:sp>
+      <p:sp>
+        <p:nvSpPr>
+          <p:cNvPr id="127" name="Google Shape;127;p21"/>
+          <p:cNvSpPr/>
+          <p:nvPr/>
+        </p:nvSpPr>
+        <p:spPr>
+          <a:xfrm>
+            <a:off x="5800251" y="4186378"/>
+            <a:ext cx="120300" cy="121500"/>
+          </a:xfrm>
+          <a:prstGeom prst="ellipse">
+            <a:avLst/>
+          </a:prstGeom>
+          <a:solidFill>
+            <a:srgbClr val="FF0000"/>
+          </a:solidFill>
+          <a:ln cap="flat" cmpd="sng" w="9525">
+            <a:solidFill>
+              <a:schemeClr val="dk2"/>
+            </a:solidFill>
+            <a:prstDash val="solid"/>
+            <a:round/>
+            <a:headEnd len="sm" w="sm" type="none"/>
+            <a:tailEnd len="sm" w="sm" type="none"/>
+          </a:ln>
+        </p:spPr>
+        <p:txBody>
+          <a:bodyPr anchorCtr="0" anchor="ctr" bIns="91425" lIns="91425" spcFirstLastPara="1" rIns="91425" wrap="square" tIns="91425">
+            <a:noAutofit/>
+          </a:bodyPr>
+          <a:lstStyle/>
+          <a:p>
+            <a:pPr indent="0" lvl="0" marL="0" rtl="0" algn="ctr">
+              <a:spcBef>
+                <a:spcPts val="0"/>
+              </a:spcBef>
+              <a:spcAft>
+                <a:spcPts val="0"/>
+              </a:spcAft>
+              <a:buNone/>
+            </a:pPr>
+            <a:r>
+              <a:t/>
+            </a:r>
+            <a:endParaRPr/>
+          </a:p>
+        </p:txBody>
+      </p:sp>
+      <p:sp>
+        <p:nvSpPr>
+          <p:cNvPr id="128" name="Google Shape;128;p21"/>
+          <p:cNvSpPr/>
+          <p:nvPr/>
+        </p:nvSpPr>
+        <p:spPr>
+          <a:xfrm>
+            <a:off x="7130648" y="4283591"/>
+            <a:ext cx="120300" cy="121500"/>
+          </a:xfrm>
+          <a:prstGeom prst="ellipse">
+            <a:avLst/>
+          </a:prstGeom>
+          <a:solidFill>
+            <a:srgbClr val="980000"/>
+          </a:solidFill>
+          <a:ln cap="flat" cmpd="sng" w="9525">
+            <a:solidFill>
+              <a:schemeClr val="dk2"/>
+            </a:solidFill>
+            <a:prstDash val="solid"/>
+            <a:round/>
+            <a:headEnd len="sm" w="sm" type="none"/>
+            <a:tailEnd len="sm" w="sm" type="none"/>
+          </a:ln>
+        </p:spPr>
+        <p:txBody>
+          <a:bodyPr anchorCtr="0" anchor="ctr" bIns="91425" lIns="91425" spcFirstLastPara="1" rIns="91425" wrap="square" tIns="91425">
+            <a:noAutofit/>
+          </a:bodyPr>
+          <a:lstStyle/>
+          <a:p>
+            <a:pPr indent="0" lvl="0" marL="0" rtl="0" algn="ctr">
+              <a:spcBef>
+                <a:spcPts val="0"/>
+              </a:spcBef>
+              <a:spcAft>
+                <a:spcPts val="0"/>
+              </a:spcAft>
+              <a:buNone/>
+            </a:pPr>
+            <a:r>
+              <a:t/>
+            </a:r>
+            <a:endParaRPr/>
+          </a:p>
+        </p:txBody>
+      </p:sp>
+      <p:sp>
+        <p:nvSpPr>
+          <p:cNvPr id="129" name="Google Shape;129;p21"/>
+          <p:cNvSpPr txBox="1"/>
+          <p:nvPr>
+            <p:ph idx="1" type="body"/>
+          </p:nvPr>
+        </p:nvSpPr>
+        <p:spPr>
+          <a:xfrm>
+            <a:off x="7409350" y="3469775"/>
+            <a:ext cx="1587300" cy="572700"/>
+          </a:xfrm>
+          <a:prstGeom prst="rect">
+            <a:avLst/>
+          </a:prstGeom>
+        </p:spPr>
+        <p:txBody>
+          <a:bodyPr anchorCtr="0" anchor="t" bIns="91425" lIns="91425" spcFirstLastPara="1" rIns="91425" wrap="square" tIns="91425">
+            <a:noAutofit/>
+          </a:bodyPr>
+          <a:lstStyle/>
+          <a:p>
+            <a:pPr indent="0" lvl="0" marL="0" rtl="0" algn="l">
+              <a:spcBef>
+                <a:spcPts val="0"/>
+              </a:spcBef>
+              <a:spcAft>
+                <a:spcPts val="1200"/>
+              </a:spcAft>
+              <a:buNone/>
+            </a:pPr>
+            <a:r>
+              <a:rPr lang="en" sz="800"/>
+              <a:t>Financiamento concentrado em cidades com pouco retorno</a:t>
+            </a:r>
+            <a:endParaRPr sz="800"/>
+          </a:p>
+        </p:txBody>
+      </p:sp>
+      <p:sp>
+        <p:nvSpPr>
+          <p:cNvPr id="130" name="Google Shape;130;p21"/>
+          <p:cNvSpPr/>
+          <p:nvPr/>
+        </p:nvSpPr>
+        <p:spPr>
+          <a:xfrm>
+            <a:off x="6932725" y="3850825"/>
+            <a:ext cx="1834800" cy="624300"/>
+          </a:xfrm>
+          <a:prstGeom prst="roundRect">
+            <a:avLst>
+              <a:gd fmla="val 16667" name="adj"/>
+            </a:avLst>
+          </a:prstGeom>
+          <a:solidFill>
+            <a:srgbClr val="FF0000">
+              <a:alpha val="18000"/>
+            </a:srgbClr>
+          </a:solidFill>
+          <a:ln>
+            <a:noFill/>
+          </a:ln>
+        </p:spPr>
+        <p:txBody>
+          <a:bodyPr anchorCtr="0" anchor="ctr" bIns="91425" lIns="91425" spcFirstLastPara="1" rIns="91425" wrap="square" tIns="91425">
+            <a:noAutofit/>
+          </a:bodyPr>
+          <a:lstStyle/>
+          <a:p>
+            <a:pPr indent="0" lvl="0" marL="0" rtl="0" algn="ctr">
+              <a:spcBef>
+                <a:spcPts val="0"/>
+              </a:spcBef>
+              <a:spcAft>
+                <a:spcPts val="0"/>
+              </a:spcAft>
+              <a:buNone/>
+            </a:pPr>
+            <a:r>
+              <a:t/>
+            </a:r>
+            <a:endParaRPr/>
           </a:p>
         </p:txBody>
       </p:sp>
@@ -8955,6 +11921,285 @@
 </file>
 
 <file path=ppt/theme/theme1.xml><?xml version="1.0" encoding="utf-8"?>
+<a:theme xmlns:a="http://schemas.openxmlformats.org/drawingml/2006/main" xmlns:r="http://schemas.openxmlformats.org/officeDocument/2006/relationships">
+  <a:themeElements>
+    <a:clrScheme name="Default">
+      <a:dk1>
+        <a:srgbClr val="000000"/>
+      </a:dk1>
+      <a:lt1>
+        <a:srgbClr val="FFFFFF"/>
+      </a:lt1>
+      <a:dk2>
+        <a:srgbClr val="158158"/>
+      </a:dk2>
+      <a:lt2>
+        <a:srgbClr val="F3F3F3"/>
+      </a:lt2>
+      <a:accent1>
+        <a:srgbClr val="058DC7"/>
+      </a:accent1>
+      <a:accent2>
+        <a:srgbClr val="50B432"/>
+      </a:accent2>
+      <a:accent3>
+        <a:srgbClr val="ED561B"/>
+      </a:accent3>
+      <a:accent4>
+        <a:srgbClr val="EDEF00"/>
+      </a:accent4>
+      <a:accent5>
+        <a:srgbClr val="24CBE5"/>
+      </a:accent5>
+      <a:accent6>
+        <a:srgbClr val="64E572"/>
+      </a:accent6>
+      <a:hlink>
+        <a:srgbClr val="2200CC"/>
+      </a:hlink>
+      <a:folHlink>
+        <a:srgbClr val="551A8B"/>
+      </a:folHlink>
+    </a:clrScheme>
+    <a:fontScheme name="Office">
+      <a:majorFont>
+        <a:latin typeface="Arial"/>
+        <a:ea typeface=""/>
+        <a:cs typeface=""/>
+        <a:font script="Jpan" typeface="ＭＳ Ｐゴシック"/>
+        <a:font script="Hang" typeface="맑은 고딕"/>
+        <a:font script="Hans" typeface="宋体"/>
+        <a:font script="Hant" typeface="新細明體"/>
+        <a:font script="Arab" typeface="Times New Roman"/>
+        <a:font script="Hebr" typeface="Times New Roman"/>
+        <a:font script="Thai" typeface="Angsana New"/>
+        <a:font script="Ethi" typeface="Nyala"/>
+        <a:font script="Beng" typeface="Vrinda"/>
+        <a:font script="Gujr" typeface="Shruti"/>
+        <a:font script="Khmr" typeface="MoolBoran"/>
+        <a:font script="Knda" typeface="Tunga"/>
+        <a:font script="Guru" typeface="Raavi"/>
+        <a:font script="Cans" typeface="Euphemia"/>
+        <a:font script="Cher" typeface="Plantagenet Cherokee"/>
+        <a:font script="Yiii" typeface="Microsoft Yi Baiti"/>
+        <a:font script="Tibt" typeface="Microsoft Himalaya"/>
+        <a:font script="Thaa" typeface="MV Boli"/>
+        <a:font script="Deva" typeface="Mangal"/>
+        <a:font script="Telu" typeface="Gautami"/>
+        <a:font script="Taml" typeface="Latha"/>
+        <a:font script="Syrc" typeface="Estrangelo Edessa"/>
+        <a:font script="Orya" typeface="Kalinga"/>
+        <a:font script="Mlym" typeface="Kartika"/>
+        <a:font script="Laoo" typeface="DokChampa"/>
+        <a:font script="Sinh" typeface="Iskoola Pota"/>
+        <a:font script="Mong" typeface="Mongolian Baiti"/>
+        <a:font script="Viet" typeface="Times New Roman"/>
+        <a:font script="Uigh" typeface="Microsoft Uighur"/>
+        <a:font script="Geor" typeface="Sylfaen"/>
+      </a:majorFont>
+      <a:minorFont>
+        <a:latin typeface="Arial"/>
+        <a:ea typeface=""/>
+        <a:cs typeface=""/>
+        <a:font script="Jpan" typeface="ＭＳ Ｐゴシック"/>
+        <a:font script="Hang" typeface="맑은 고딕"/>
+        <a:font script="Hans" typeface="宋体"/>
+        <a:font script="Hant" typeface="新細明體"/>
+        <a:font script="Arab" typeface="Arial"/>
+        <a:font script="Hebr" typeface="Arial"/>
+        <a:font script="Thai" typeface="Cordia New"/>
+        <a:font script="Ethi" typeface="Nyala"/>
+        <a:font script="Beng" typeface="Vrinda"/>
+        <a:font script="Gujr" typeface="Shruti"/>
+        <a:font script="Khmr" typeface="DaunPenh"/>
+        <a:font script="Knda" typeface="Tunga"/>
+        <a:font script="Guru" typeface="Raavi"/>
+        <a:font script="Cans" typeface="Euphemia"/>
+        <a:font script="Cher" typeface="Plantagenet Cherokee"/>
+        <a:font script="Yiii" typeface="Microsoft Yi Baiti"/>
+        <a:font script="Tibt" typeface="Microsoft Himalaya"/>
+        <a:font script="Thaa" typeface="MV Boli"/>
+        <a:font script="Deva" typeface="Mangal"/>
+        <a:font script="Telu" typeface="Gautami"/>
+        <a:font script="Taml" typeface="Latha"/>
+        <a:font script="Syrc" typeface="Estrangelo Edessa"/>
+        <a:font script="Orya" typeface="Kalinga"/>
+        <a:font script="Mlym" typeface="Kartika"/>
+        <a:font script="Laoo" typeface="DokChampa"/>
+        <a:font script="Sinh" typeface="Iskoola Pota"/>
+        <a:font script="Mong" typeface="Mongolian Baiti"/>
+        <a:font script="Viet" typeface="Arial"/>
+        <a:font script="Uigh" typeface="Microsoft Uighur"/>
+        <a:font script="Geor" typeface="Sylfaen"/>
+      </a:minorFont>
+    </a:fontScheme>
+    <a:fmtScheme name="Office">
+      <a:fillStyleLst>
+        <a:solidFill>
+          <a:schemeClr val="phClr"/>
+        </a:solidFill>
+        <a:gradFill rotWithShape="1">
+          <a:gsLst>
+            <a:gs pos="0">
+              <a:schemeClr val="phClr">
+                <a:tint val="50000"/>
+                <a:satMod val="300000"/>
+              </a:schemeClr>
+            </a:gs>
+            <a:gs pos="35000">
+              <a:schemeClr val="phClr">
+                <a:tint val="37000"/>
+                <a:satMod val="300000"/>
+              </a:schemeClr>
+            </a:gs>
+            <a:gs pos="100000">
+              <a:schemeClr val="phClr">
+                <a:tint val="15000"/>
+                <a:satMod val="350000"/>
+              </a:schemeClr>
+            </a:gs>
+          </a:gsLst>
+          <a:lin ang="16200000" scaled="1"/>
+        </a:gradFill>
+        <a:gradFill rotWithShape="1">
+          <a:gsLst>
+            <a:gs pos="0">
+              <a:schemeClr val="phClr">
+                <a:tint val="100000"/>
+                <a:shade val="100000"/>
+                <a:satMod val="130000"/>
+              </a:schemeClr>
+            </a:gs>
+            <a:gs pos="100000">
+              <a:schemeClr val="phClr">
+                <a:tint val="50000"/>
+                <a:shade val="100000"/>
+                <a:satMod val="350000"/>
+              </a:schemeClr>
+            </a:gs>
+          </a:gsLst>
+          <a:lin ang="16200000" scaled="0"/>
+        </a:gradFill>
+      </a:fillStyleLst>
+      <a:lnStyleLst>
+        <a:ln w="9525" cap="flat" cmpd="sng" algn="ctr">
+          <a:solidFill>
+            <a:schemeClr val="phClr">
+              <a:shade val="95000"/>
+              <a:satMod val="105000"/>
+            </a:schemeClr>
+          </a:solidFill>
+          <a:prstDash val="solid"/>
+        </a:ln>
+        <a:ln w="25400" cap="flat" cmpd="sng" algn="ctr">
+          <a:solidFill>
+            <a:schemeClr val="phClr"/>
+          </a:solidFill>
+          <a:prstDash val="solid"/>
+        </a:ln>
+        <a:ln w="38100" cap="flat" cmpd="sng" algn="ctr">
+          <a:solidFill>
+            <a:schemeClr val="phClr"/>
+          </a:solidFill>
+          <a:prstDash val="solid"/>
+        </a:ln>
+      </a:lnStyleLst>
+      <a:effectStyleLst>
+        <a:effectStyle>
+          <a:effectLst>
+            <a:outerShdw blurRad="40000" dist="20000" dir="5400000" rotWithShape="0">
+              <a:srgbClr val="000000">
+                <a:alpha val="38000"/>
+              </a:srgbClr>
+            </a:outerShdw>
+          </a:effectLst>
+        </a:effectStyle>
+        <a:effectStyle>
+          <a:effectLst>
+            <a:outerShdw blurRad="40000" dist="23000" dir="5400000" rotWithShape="0">
+              <a:srgbClr val="000000">
+                <a:alpha val="35000"/>
+              </a:srgbClr>
+            </a:outerShdw>
+          </a:effectLst>
+        </a:effectStyle>
+        <a:effectStyle>
+          <a:effectLst>
+            <a:outerShdw blurRad="40000" dist="23000" dir="5400000" rotWithShape="0">
+              <a:srgbClr val="000000">
+                <a:alpha val="35000"/>
+              </a:srgbClr>
+            </a:outerShdw>
+          </a:effectLst>
+          <a:scene3d>
+            <a:camera prst="orthographicFront">
+              <a:rot lat="0" lon="0" rev="0"/>
+            </a:camera>
+            <a:lightRig rig="threePt" dir="t">
+              <a:rot lat="0" lon="0" rev="1200000"/>
+            </a:lightRig>
+          </a:scene3d>
+          <a:sp3d>
+            <a:bevelT w="63500" h="25400"/>
+          </a:sp3d>
+        </a:effectStyle>
+      </a:effectStyleLst>
+      <a:bgFillStyleLst>
+        <a:solidFill>
+          <a:schemeClr val="phClr"/>
+        </a:solidFill>
+        <a:gradFill rotWithShape="1">
+          <a:gsLst>
+            <a:gs pos="0">
+              <a:schemeClr val="phClr">
+                <a:tint val="40000"/>
+                <a:satMod val="350000"/>
+              </a:schemeClr>
+            </a:gs>
+            <a:gs pos="40000">
+              <a:schemeClr val="phClr">
+                <a:tint val="45000"/>
+                <a:shade val="99000"/>
+                <a:satMod val="350000"/>
+              </a:schemeClr>
+            </a:gs>
+            <a:gs pos="100000">
+              <a:schemeClr val="phClr">
+                <a:shade val="20000"/>
+                <a:satMod val="255000"/>
+              </a:schemeClr>
+            </a:gs>
+          </a:gsLst>
+          <a:path path="circle">
+            <a:fillToRect l="50000" t="-80000" r="50000" b="180000"/>
+          </a:path>
+        </a:gradFill>
+        <a:gradFill rotWithShape="1">
+          <a:gsLst>
+            <a:gs pos="0">
+              <a:schemeClr val="phClr">
+                <a:tint val="80000"/>
+                <a:satMod val="300000"/>
+              </a:schemeClr>
+            </a:gs>
+            <a:gs pos="100000">
+              <a:schemeClr val="phClr">
+                <a:shade val="30000"/>
+                <a:satMod val="200000"/>
+              </a:schemeClr>
+            </a:gs>
+          </a:gsLst>
+          <a:path path="circle">
+            <a:fillToRect l="50000" t="50000" r="50000" b="50000"/>
+          </a:path>
+        </a:gradFill>
+      </a:bgFillStyleLst>
+    </a:fmtScheme>
+  </a:themeElements>
+</a:theme>
+</file>
+
+<file path=ppt/theme/theme2.xml><?xml version="1.0" encoding="utf-8"?>
 <a:theme xmlns:a="http://schemas.openxmlformats.org/drawingml/2006/main" xmlns:r="http://schemas.openxmlformats.org/officeDocument/2006/relationships" name="Simple Light">
   <a:themeElements>
     <a:clrScheme name="Simple Light">
@@ -9231,283 +12476,4 @@
     </a:fmtScheme>
   </a:themeElements>
 </a:theme>
-</file>
-
-<file path=ppt/theme/theme2.xml><?xml version="1.0" encoding="utf-8"?>
-<a:theme xmlns:a="http://schemas.openxmlformats.org/drawingml/2006/main" xmlns:r="http://schemas.openxmlformats.org/officeDocument/2006/relationships">
-  <a:themeElements>
-    <a:clrScheme name="Default">
-      <a:dk1>
-        <a:srgbClr val="000000"/>
-      </a:dk1>
-      <a:lt1>
-        <a:srgbClr val="FFFFFF"/>
-      </a:lt1>
-      <a:dk2>
-        <a:srgbClr val="158158"/>
-      </a:dk2>
-      <a:lt2>
-        <a:srgbClr val="F3F3F3"/>
-      </a:lt2>
-      <a:accent1>
-        <a:srgbClr val="058DC7"/>
-      </a:accent1>
-      <a:accent2>
-        <a:srgbClr val="50B432"/>
-      </a:accent2>
-      <a:accent3>
-        <a:srgbClr val="ED561B"/>
-      </a:accent3>
-      <a:accent4>
-        <a:srgbClr val="EDEF00"/>
-      </a:accent4>
-      <a:accent5>
-        <a:srgbClr val="24CBE5"/>
-      </a:accent5>
-      <a:accent6>
-        <a:srgbClr val="64E572"/>
-      </a:accent6>
-      <a:hlink>
-        <a:srgbClr val="2200CC"/>
-      </a:hlink>
-      <a:folHlink>
-        <a:srgbClr val="551A8B"/>
-      </a:folHlink>
-    </a:clrScheme>
-    <a:fontScheme name="Office">
-      <a:majorFont>
-        <a:latin typeface="Arial"/>
-        <a:ea typeface=""/>
-        <a:cs typeface=""/>
-        <a:font script="Jpan" typeface="ＭＳ Ｐゴシック"/>
-        <a:font script="Hang" typeface="맑은 고딕"/>
-        <a:font script="Hans" typeface="宋体"/>
-        <a:font script="Hant" typeface="新細明體"/>
-        <a:font script="Arab" typeface="Times New Roman"/>
-        <a:font script="Hebr" typeface="Times New Roman"/>
-        <a:font script="Thai" typeface="Angsana New"/>
-        <a:font script="Ethi" typeface="Nyala"/>
-        <a:font script="Beng" typeface="Vrinda"/>
-        <a:font script="Gujr" typeface="Shruti"/>
-        <a:font script="Khmr" typeface="MoolBoran"/>
-        <a:font script="Knda" typeface="Tunga"/>
-        <a:font script="Guru" typeface="Raavi"/>
-        <a:font script="Cans" typeface="Euphemia"/>
-        <a:font script="Cher" typeface="Plantagenet Cherokee"/>
-        <a:font script="Yiii" typeface="Microsoft Yi Baiti"/>
-        <a:font script="Tibt" typeface="Microsoft Himalaya"/>
-        <a:font script="Thaa" typeface="MV Boli"/>
-        <a:font script="Deva" typeface="Mangal"/>
-        <a:font script="Telu" typeface="Gautami"/>
-        <a:font script="Taml" typeface="Latha"/>
-        <a:font script="Syrc" typeface="Estrangelo Edessa"/>
-        <a:font script="Orya" typeface="Kalinga"/>
-        <a:font script="Mlym" typeface="Kartika"/>
-        <a:font script="Laoo" typeface="DokChampa"/>
-        <a:font script="Sinh" typeface="Iskoola Pota"/>
-        <a:font script="Mong" typeface="Mongolian Baiti"/>
-        <a:font script="Viet" typeface="Times New Roman"/>
-        <a:font script="Uigh" typeface="Microsoft Uighur"/>
-        <a:font script="Geor" typeface="Sylfaen"/>
-      </a:majorFont>
-      <a:minorFont>
-        <a:latin typeface="Arial"/>
-        <a:ea typeface=""/>
-        <a:cs typeface=""/>
-        <a:font script="Jpan" typeface="ＭＳ Ｐゴシック"/>
-        <a:font script="Hang" typeface="맑은 고딕"/>
-        <a:font script="Hans" typeface="宋体"/>
-        <a:font script="Hant" typeface="新細明體"/>
-        <a:font script="Arab" typeface="Arial"/>
-        <a:font script="Hebr" typeface="Arial"/>
-        <a:font script="Thai" typeface="Cordia New"/>
-        <a:font script="Ethi" typeface="Nyala"/>
-        <a:font script="Beng" typeface="Vrinda"/>
-        <a:font script="Gujr" typeface="Shruti"/>
-        <a:font script="Khmr" typeface="DaunPenh"/>
-        <a:font script="Knda" typeface="Tunga"/>
-        <a:font script="Guru" typeface="Raavi"/>
-        <a:font script="Cans" typeface="Euphemia"/>
-        <a:font script="Cher" typeface="Plantagenet Cherokee"/>
-        <a:font script="Yiii" typeface="Microsoft Yi Baiti"/>
-        <a:font script="Tibt" typeface="Microsoft Himalaya"/>
-        <a:font script="Thaa" typeface="MV Boli"/>
-        <a:font script="Deva" typeface="Mangal"/>
-        <a:font script="Telu" typeface="Gautami"/>
-        <a:font script="Taml" typeface="Latha"/>
-        <a:font script="Syrc" typeface="Estrangelo Edessa"/>
-        <a:font script="Orya" typeface="Kalinga"/>
-        <a:font script="Mlym" typeface="Kartika"/>
-        <a:font script="Laoo" typeface="DokChampa"/>
-        <a:font script="Sinh" typeface="Iskoola Pota"/>
-        <a:font script="Mong" typeface="Mongolian Baiti"/>
-        <a:font script="Viet" typeface="Arial"/>
-        <a:font script="Uigh" typeface="Microsoft Uighur"/>
-        <a:font script="Geor" typeface="Sylfaen"/>
-      </a:minorFont>
-    </a:fontScheme>
-    <a:fmtScheme name="Office">
-      <a:fillStyleLst>
-        <a:solidFill>
-          <a:schemeClr val="phClr"/>
-        </a:solidFill>
-        <a:gradFill rotWithShape="1">
-          <a:gsLst>
-            <a:gs pos="0">
-              <a:schemeClr val="phClr">
-                <a:tint val="50000"/>
-                <a:satMod val="300000"/>
-              </a:schemeClr>
-            </a:gs>
-            <a:gs pos="35000">
-              <a:schemeClr val="phClr">
-                <a:tint val="37000"/>
-                <a:satMod val="300000"/>
-              </a:schemeClr>
-            </a:gs>
-            <a:gs pos="100000">
-              <a:schemeClr val="phClr">
-                <a:tint val="15000"/>
-                <a:satMod val="350000"/>
-              </a:schemeClr>
-            </a:gs>
-          </a:gsLst>
-          <a:lin ang="16200000" scaled="1"/>
-        </a:gradFill>
-        <a:gradFill rotWithShape="1">
-          <a:gsLst>
-            <a:gs pos="0">
-              <a:schemeClr val="phClr">
-                <a:tint val="100000"/>
-                <a:shade val="100000"/>
-                <a:satMod val="130000"/>
-              </a:schemeClr>
-            </a:gs>
-            <a:gs pos="100000">
-              <a:schemeClr val="phClr">
-                <a:tint val="50000"/>
-                <a:shade val="100000"/>
-                <a:satMod val="350000"/>
-              </a:schemeClr>
-            </a:gs>
-          </a:gsLst>
-          <a:lin ang="16200000" scaled="0"/>
-        </a:gradFill>
-      </a:fillStyleLst>
-      <a:lnStyleLst>
-        <a:ln w="9525" cap="flat" cmpd="sng" algn="ctr">
-          <a:solidFill>
-            <a:schemeClr val="phClr">
-              <a:shade val="95000"/>
-              <a:satMod val="105000"/>
-            </a:schemeClr>
-          </a:solidFill>
-          <a:prstDash val="solid"/>
-        </a:ln>
-        <a:ln w="25400" cap="flat" cmpd="sng" algn="ctr">
-          <a:solidFill>
-            <a:schemeClr val="phClr"/>
-          </a:solidFill>
-          <a:prstDash val="solid"/>
-        </a:ln>
-        <a:ln w="38100" cap="flat" cmpd="sng" algn="ctr">
-          <a:solidFill>
-            <a:schemeClr val="phClr"/>
-          </a:solidFill>
-          <a:prstDash val="solid"/>
-        </a:ln>
-      </a:lnStyleLst>
-      <a:effectStyleLst>
-        <a:effectStyle>
-          <a:effectLst>
-            <a:outerShdw blurRad="40000" dist="20000" dir="5400000" rotWithShape="0">
-              <a:srgbClr val="000000">
-                <a:alpha val="38000"/>
-              </a:srgbClr>
-            </a:outerShdw>
-          </a:effectLst>
-        </a:effectStyle>
-        <a:effectStyle>
-          <a:effectLst>
-            <a:outerShdw blurRad="40000" dist="23000" dir="5400000" rotWithShape="0">
-              <a:srgbClr val="000000">
-                <a:alpha val="35000"/>
-              </a:srgbClr>
-            </a:outerShdw>
-          </a:effectLst>
-        </a:effectStyle>
-        <a:effectStyle>
-          <a:effectLst>
-            <a:outerShdw blurRad="40000" dist="23000" dir="5400000" rotWithShape="0">
-              <a:srgbClr val="000000">
-                <a:alpha val="35000"/>
-              </a:srgbClr>
-            </a:outerShdw>
-          </a:effectLst>
-          <a:scene3d>
-            <a:camera prst="orthographicFront">
-              <a:rot lat="0" lon="0" rev="0"/>
-            </a:camera>
-            <a:lightRig rig="threePt" dir="t">
-              <a:rot lat="0" lon="0" rev="1200000"/>
-            </a:lightRig>
-          </a:scene3d>
-          <a:sp3d>
-            <a:bevelT w="63500" h="25400"/>
-          </a:sp3d>
-        </a:effectStyle>
-      </a:effectStyleLst>
-      <a:bgFillStyleLst>
-        <a:solidFill>
-          <a:schemeClr val="phClr"/>
-        </a:solidFill>
-        <a:gradFill rotWithShape="1">
-          <a:gsLst>
-            <a:gs pos="0">
-              <a:schemeClr val="phClr">
-                <a:tint val="40000"/>
-                <a:satMod val="350000"/>
-              </a:schemeClr>
-            </a:gs>
-            <a:gs pos="40000">
-              <a:schemeClr val="phClr">
-                <a:tint val="45000"/>
-                <a:shade val="99000"/>
-                <a:satMod val="350000"/>
-              </a:schemeClr>
-            </a:gs>
-            <a:gs pos="100000">
-              <a:schemeClr val="phClr">
-                <a:shade val="20000"/>
-                <a:satMod val="255000"/>
-              </a:schemeClr>
-            </a:gs>
-          </a:gsLst>
-          <a:path path="circle">
-            <a:fillToRect l="50000" t="-80000" r="50000" b="180000"/>
-          </a:path>
-        </a:gradFill>
-        <a:gradFill rotWithShape="1">
-          <a:gsLst>
-            <a:gs pos="0">
-              <a:schemeClr val="phClr">
-                <a:tint val="80000"/>
-                <a:satMod val="300000"/>
-              </a:schemeClr>
-            </a:gs>
-            <a:gs pos="100000">
-              <a:schemeClr val="phClr">
-                <a:shade val="30000"/>
-                <a:satMod val="200000"/>
-              </a:schemeClr>
-            </a:gs>
-          </a:gsLst>
-          <a:path path="circle">
-            <a:fillToRect l="50000" t="50000" r="50000" b="50000"/>
-          </a:path>
-        </a:gradFill>
-      </a:bgFillStyleLst>
-    </a:fmtScheme>
-  </a:themeElements>
-</a:theme>
 </file>
</xml_diff>